<commit_message>
fix(presentation): remove 'PPT FORMAT' line from title slide in PPTX and PDF
</commit_message>
<xml_diff>
--- a/Team_Phoenix_INIT26_Presentation.pptx
+++ b/Team_Phoenix_INIT26_Presentation.pptx
@@ -22,15 +22,11 @@
       <p:regular r:id="rId10"/>
     </p:embeddedFont>
     <p:embeddedFont>
-      <p:font typeface="Poppins Bold" panose="020B0604020202020204" charset="0"/>
+      <p:font typeface="Segoe UI" panose="020B0502040204020203" pitchFamily="34" charset="0"/>
       <p:regular r:id="rId11"/>
-    </p:embeddedFont>
-    <p:embeddedFont>
-      <p:font typeface="Segoe UI" panose="020B0502040204020203" pitchFamily="34" charset="0"/>
-      <p:regular r:id="rId12"/>
-      <p:bold r:id="rId13"/>
-      <p:italic r:id="rId14"/>
-      <p:boldItalic r:id="rId15"/>
+      <p:bold r:id="rId12"/>
+      <p:italic r:id="rId13"/>
+      <p:boldItalic r:id="rId14"/>
     </p:embeddedFont>
   </p:embeddedFontLst>
   <p:defaultTextStyle>
@@ -3490,47 +3486,6 @@
       </p:grpSp>
       <p:sp>
         <p:nvSpPr>
-          <p:cNvPr id="11" name="TextBox 11"/>
-          <p:cNvSpPr txBox="1"/>
-          <p:nvPr/>
-        </p:nvSpPr>
-        <p:spPr>
-          <a:xfrm>
-            <a:off x="3057077" y="6482451"/>
-            <a:ext cx="12745346" cy="1314450"/>
-          </a:xfrm>
-          <a:prstGeom prst="rect">
-            <a:avLst/>
-          </a:prstGeom>
-        </p:spPr>
-        <p:txBody>
-          <a:bodyPr lIns="0" tIns="0" rIns="0" bIns="0" rtlCol="0" anchor="t">
-            <a:spAutoFit/>
-          </a:bodyPr>
-          <a:lstStyle/>
-          <a:p>
-            <a:pPr algn="ctr">
-              <a:lnSpc>
-                <a:spcPts val="10050"/>
-              </a:lnSpc>
-            </a:pPr>
-            <a:r>
-              <a:rPr lang="en-US" sz="7500" b="1">
-                <a:solidFill>
-                  <a:srgbClr val="2DAF4B"/>
-                </a:solidFill>
-                <a:latin typeface="Poppins Bold"/>
-                <a:ea typeface="Poppins Bold"/>
-                <a:cs typeface="Poppins Bold"/>
-                <a:sym typeface="Poppins Bold"/>
-              </a:rPr>
-              <a:t>PPT FORMAT</a:t>
-            </a:r>
-          </a:p>
-        </p:txBody>
-      </p:sp>
-      <p:sp>
-        <p:nvSpPr>
           <p:cNvPr id="21" name="AutoShape 21"/>
           <p:cNvSpPr/>
           <p:nvPr/>
@@ -3562,51 +3517,10 @@
       </p:sp>
       <p:sp>
         <p:nvSpPr>
-          <p:cNvPr id="23" name="TextBox 23"/>
-          <p:cNvSpPr txBox="1"/>
-          <p:nvPr/>
-        </p:nvSpPr>
-        <p:spPr>
-          <a:xfrm>
-            <a:off x="3057077" y="7378118"/>
-            <a:ext cx="12745346" cy="1314450"/>
-          </a:xfrm>
-          <a:prstGeom prst="rect">
-            <a:avLst/>
-          </a:prstGeom>
-        </p:spPr>
-        <p:txBody>
-          <a:bodyPr lIns="0" tIns="0" rIns="0" bIns="0" rtlCol="0" anchor="t">
-            <a:spAutoFit/>
-          </a:bodyPr>
-          <a:lstStyle/>
-          <a:p>
-            <a:pPr algn="ctr">
-              <a:lnSpc>
-                <a:spcPts val="10050"/>
-              </a:lnSpc>
-            </a:pPr>
-            <a:r>
-              <a:rPr lang="en-US" sz="7500" b="1">
-                <a:solidFill>
-                  <a:srgbClr val="000000"/>
-                </a:solidFill>
-                <a:latin typeface="Poppins Bold"/>
-                <a:ea typeface="Poppins Bold"/>
-                <a:cs typeface="Poppins Bold"/>
-                <a:sym typeface="Poppins Bold"/>
-              </a:rPr>
-              <a:t>(</a:t>
-            </a:r>
-          </a:p>
-        </p:txBody>
-      </p:sp>
-      <p:sp>
-        <p:nvSpPr>
           <p:cNvPr id="12" name="Rectangle: Rounded Corners 11">
             <a:extLst>
               <a:ext uri="{FF2B5EF4-FFF2-40B4-BE49-F238E27FC236}">
-                <a16:creationId xmlns:a16="http://schemas.microsoft.com/office/drawing/2014/main" id="{71A2ED19-7B44-BC15-EA29-E123029175B7}"/>
+                <a16:creationId xmlns:a16="http://schemas.microsoft.com/office/drawing/2014/main" id="{7626922B-8AB6-3549-8DC8-BCAA87C73D44}"/>
               </a:ext>
             </a:extLst>
           </p:cNvPr>
@@ -3615,8 +3529,8 @@
         </p:nvSpPr>
         <p:spPr>
           <a:xfrm>
-            <a:off x="4343400" y="8509000"/>
-            <a:ext cx="10160000" cy="635000"/>
+            <a:off x="4038600" y="7493000"/>
+            <a:ext cx="10795000" cy="660400"/>
           </a:xfrm>
           <a:prstGeom prst="roundRect">
             <a:avLst/>
@@ -3734,7 +3648,7 @@
           <p:cNvPr id="2" name="Rectangle: Rounded Corners 1">
             <a:extLst>
               <a:ext uri="{FF2B5EF4-FFF2-40B4-BE49-F238E27FC236}">
-                <a16:creationId xmlns:a16="http://schemas.microsoft.com/office/drawing/2014/main" id="{957487BC-AF5B-140E-ECCD-0080B9FC7992}"/>
+                <a16:creationId xmlns:a16="http://schemas.microsoft.com/office/drawing/2014/main" id="{72C4742E-A88E-62A3-DEEA-20E15A8B313B}"/>
               </a:ext>
             </a:extLst>
           </p:cNvPr>
@@ -3973,7 +3887,7 @@
           <p:cNvPr id="2" name="Rectangle: Rounded Corners 1">
             <a:extLst>
               <a:ext uri="{FF2B5EF4-FFF2-40B4-BE49-F238E27FC236}">
-                <a16:creationId xmlns:a16="http://schemas.microsoft.com/office/drawing/2014/main" id="{27D49267-4710-5D61-DBB2-C0DF5AAD6070}"/>
+                <a16:creationId xmlns:a16="http://schemas.microsoft.com/office/drawing/2014/main" id="{089586ED-C921-E2B2-1E68-403551735BC3}"/>
               </a:ext>
             </a:extLst>
           </p:cNvPr>
@@ -4119,7 +4033,7 @@
           <p:cNvPr id="3" name="Rectangle: Rounded Corners 2">
             <a:extLst>
               <a:ext uri="{FF2B5EF4-FFF2-40B4-BE49-F238E27FC236}">
-                <a16:creationId xmlns:a16="http://schemas.microsoft.com/office/drawing/2014/main" id="{B9B985C6-D71E-0974-FADB-6B8AA03B4158}"/>
+                <a16:creationId xmlns:a16="http://schemas.microsoft.com/office/drawing/2014/main" id="{1212EF2E-A0F9-4769-F5FE-9DFB928064B8}"/>
               </a:ext>
             </a:extLst>
           </p:cNvPr>
@@ -4265,7 +4179,7 @@
           <p:cNvPr id="5" name="Rectangle: Rounded Corners 4">
             <a:extLst>
               <a:ext uri="{FF2B5EF4-FFF2-40B4-BE49-F238E27FC236}">
-                <a16:creationId xmlns:a16="http://schemas.microsoft.com/office/drawing/2014/main" id="{F8ABE333-974F-B9F1-DCE5-E5C7C6E2E971}"/>
+                <a16:creationId xmlns:a16="http://schemas.microsoft.com/office/drawing/2014/main" id="{F8D7B31E-A603-87EC-6F2C-6724108CC596}"/>
               </a:ext>
             </a:extLst>
           </p:cNvPr>
@@ -4477,7 +4391,7 @@
           <p:cNvPr id="2" name="Rectangle: Rounded Corners 1">
             <a:extLst>
               <a:ext uri="{FF2B5EF4-FFF2-40B4-BE49-F238E27FC236}">
-                <a16:creationId xmlns:a16="http://schemas.microsoft.com/office/drawing/2014/main" id="{3757FAC3-44E4-EA2D-55A9-8C7CF494C16B}"/>
+                <a16:creationId xmlns:a16="http://schemas.microsoft.com/office/drawing/2014/main" id="{4779C81C-E4DB-768B-1BD3-9430539B0736}"/>
               </a:ext>
             </a:extLst>
           </p:cNvPr>
@@ -4587,7 +4501,7 @@
           <p:cNvPr id="3" name="Rectangle: Rounded Corners 2">
             <a:extLst>
               <a:ext uri="{FF2B5EF4-FFF2-40B4-BE49-F238E27FC236}">
-                <a16:creationId xmlns:a16="http://schemas.microsoft.com/office/drawing/2014/main" id="{1B22DCAF-3E56-EFB5-8DB9-B1A4FAF29D7C}"/>
+                <a16:creationId xmlns:a16="http://schemas.microsoft.com/office/drawing/2014/main" id="{9A163D25-F3A6-3F1D-F5C0-AA214AF5C195}"/>
               </a:ext>
             </a:extLst>
           </p:cNvPr>
@@ -4697,7 +4611,7 @@
           <p:cNvPr id="5" name="Rectangle: Rounded Corners 4">
             <a:extLst>
               <a:ext uri="{FF2B5EF4-FFF2-40B4-BE49-F238E27FC236}">
-                <a16:creationId xmlns:a16="http://schemas.microsoft.com/office/drawing/2014/main" id="{40C45CB8-2A1D-4547-29A7-67BC92528751}"/>
+                <a16:creationId xmlns:a16="http://schemas.microsoft.com/office/drawing/2014/main" id="{7A76F398-5352-4055-D316-F0E6DA9F2C73}"/>
               </a:ext>
             </a:extLst>
           </p:cNvPr>
@@ -4807,7 +4721,7 @@
           <p:cNvPr id="6" name="Rectangle: Rounded Corners 5">
             <a:extLst>
               <a:ext uri="{FF2B5EF4-FFF2-40B4-BE49-F238E27FC236}">
-                <a16:creationId xmlns:a16="http://schemas.microsoft.com/office/drawing/2014/main" id="{C1B8BC44-FE2B-0649-8E9B-9A8675EFB9BA}"/>
+                <a16:creationId xmlns:a16="http://schemas.microsoft.com/office/drawing/2014/main" id="{D21F9FAE-BD49-88FD-899A-0973B37D1190}"/>
               </a:ext>
             </a:extLst>
           </p:cNvPr>
@@ -4983,7 +4897,7 @@
           <p:cNvPr id="2" name="Rectangle: Rounded Corners 1">
             <a:extLst>
               <a:ext uri="{FF2B5EF4-FFF2-40B4-BE49-F238E27FC236}">
-                <a16:creationId xmlns:a16="http://schemas.microsoft.com/office/drawing/2014/main" id="{A931FC0D-51BE-52E2-74AA-FCFD03D99329}"/>
+                <a16:creationId xmlns:a16="http://schemas.microsoft.com/office/drawing/2014/main" id="{DC9FD2A8-8A14-F19F-0FC1-EF7BAAA14BED}"/>
               </a:ext>
             </a:extLst>
           </p:cNvPr>
@@ -5066,7 +4980,7 @@
           <p:cNvPr id="3" name="Rectangle: Rounded Corners 2">
             <a:extLst>
               <a:ext uri="{FF2B5EF4-FFF2-40B4-BE49-F238E27FC236}">
-                <a16:creationId xmlns:a16="http://schemas.microsoft.com/office/drawing/2014/main" id="{B9DDDDE3-00C6-781E-37F4-909F0CFD6809}"/>
+                <a16:creationId xmlns:a16="http://schemas.microsoft.com/office/drawing/2014/main" id="{62506BBB-2039-037C-6CB6-E3E4E3BBA118}"/>
               </a:ext>
             </a:extLst>
           </p:cNvPr>
@@ -5149,7 +5063,7 @@
           <p:cNvPr id="5" name="Rectangle: Rounded Corners 4">
             <a:extLst>
               <a:ext uri="{FF2B5EF4-FFF2-40B4-BE49-F238E27FC236}">
-                <a16:creationId xmlns:a16="http://schemas.microsoft.com/office/drawing/2014/main" id="{C0E3DE09-7834-46E9-026A-1414CDDA012C}"/>
+                <a16:creationId xmlns:a16="http://schemas.microsoft.com/office/drawing/2014/main" id="{7485681F-8805-977E-718A-467DE8AEE75A}"/>
               </a:ext>
             </a:extLst>
           </p:cNvPr>
@@ -5232,7 +5146,7 @@
           <p:cNvPr id="6" name="Rectangle: Rounded Corners 5">
             <a:extLst>
               <a:ext uri="{FF2B5EF4-FFF2-40B4-BE49-F238E27FC236}">
-                <a16:creationId xmlns:a16="http://schemas.microsoft.com/office/drawing/2014/main" id="{73D7B16A-C03C-358D-C5FB-A587A92520F6}"/>
+                <a16:creationId xmlns:a16="http://schemas.microsoft.com/office/drawing/2014/main" id="{8DCD9808-15B7-1054-0B76-5AC4ED87E22C}"/>
               </a:ext>
             </a:extLst>
           </p:cNvPr>
@@ -5315,7 +5229,7 @@
           <p:cNvPr id="7" name="Rectangle: Rounded Corners 6">
             <a:extLst>
               <a:ext uri="{FF2B5EF4-FFF2-40B4-BE49-F238E27FC236}">
-                <a16:creationId xmlns:a16="http://schemas.microsoft.com/office/drawing/2014/main" id="{59B52FCC-53C3-5B47-4118-94773CFCD692}"/>
+                <a16:creationId xmlns:a16="http://schemas.microsoft.com/office/drawing/2014/main" id="{BD934FA4-53FE-441F-74F1-1C804A0212F0}"/>
               </a:ext>
             </a:extLst>
           </p:cNvPr>
@@ -5398,7 +5312,7 @@
           <p:cNvPr id="8" name="Rectangle: Rounded Corners 7">
             <a:extLst>
               <a:ext uri="{FF2B5EF4-FFF2-40B4-BE49-F238E27FC236}">
-                <a16:creationId xmlns:a16="http://schemas.microsoft.com/office/drawing/2014/main" id="{65661B17-FF1F-BE4A-94F8-9BF0EEAA5100}"/>
+                <a16:creationId xmlns:a16="http://schemas.microsoft.com/office/drawing/2014/main" id="{F17496D9-2AF6-DDD6-0FCB-E8E918D8A68F}"/>
               </a:ext>
             </a:extLst>
           </p:cNvPr>
@@ -5547,7 +5461,7 @@
           <p:cNvPr id="2" name="Rectangle: Rounded Corners 1">
             <a:extLst>
               <a:ext uri="{FF2B5EF4-FFF2-40B4-BE49-F238E27FC236}">
-                <a16:creationId xmlns:a16="http://schemas.microsoft.com/office/drawing/2014/main" id="{57548286-51B3-D33E-3669-8A6CB1A56A9C}"/>
+                <a16:creationId xmlns:a16="http://schemas.microsoft.com/office/drawing/2014/main" id="{2D2B51CC-07E4-7F9F-BB7D-279D8B9B1C4F}"/>
               </a:ext>
             </a:extLst>
           </p:cNvPr>
@@ -5601,7 +5515,7 @@
           <p:cNvPr id="5" name="Picture 4">
             <a:extLst>
               <a:ext uri="{FF2B5EF4-FFF2-40B4-BE49-F238E27FC236}">
-                <a16:creationId xmlns:a16="http://schemas.microsoft.com/office/drawing/2014/main" id="{23D27329-FB7F-5034-877A-BF3612A29E1E}"/>
+                <a16:creationId xmlns:a16="http://schemas.microsoft.com/office/drawing/2014/main" id="{8B53CA76-E90C-E4C0-6D0F-84AF8F1FDFF0}"/>
               </a:ext>
             </a:extLst>
           </p:cNvPr>
@@ -5637,7 +5551,7 @@
           <p:cNvPr id="6" name="TextBox 5">
             <a:extLst>
               <a:ext uri="{FF2B5EF4-FFF2-40B4-BE49-F238E27FC236}">
-                <a16:creationId xmlns:a16="http://schemas.microsoft.com/office/drawing/2014/main" id="{DBBF3ED8-C455-0BC4-C4A6-12E4F131BB97}"/>
+                <a16:creationId xmlns:a16="http://schemas.microsoft.com/office/drawing/2014/main" id="{88037A8D-50BC-EE1D-6107-F19E0837CD86}"/>
               </a:ext>
             </a:extLst>
           </p:cNvPr>
@@ -5688,7 +5602,7 @@
           <p:cNvPr id="7" name="Rectangle: Rounded Corners 6">
             <a:extLst>
               <a:ext uri="{FF2B5EF4-FFF2-40B4-BE49-F238E27FC236}">
-                <a16:creationId xmlns:a16="http://schemas.microsoft.com/office/drawing/2014/main" id="{6081E828-0743-FD11-104B-6C293DA36475}"/>
+                <a16:creationId xmlns:a16="http://schemas.microsoft.com/office/drawing/2014/main" id="{2E0D7508-BF85-063F-F2C2-B02CE6D5D665}"/>
               </a:ext>
             </a:extLst>
           </p:cNvPr>
@@ -5742,7 +5656,7 @@
           <p:cNvPr id="9" name="Picture 8">
             <a:extLst>
               <a:ext uri="{FF2B5EF4-FFF2-40B4-BE49-F238E27FC236}">
-                <a16:creationId xmlns:a16="http://schemas.microsoft.com/office/drawing/2014/main" id="{3E4A35C0-7B8C-4DEE-DE95-7EB21291D9D5}"/>
+                <a16:creationId xmlns:a16="http://schemas.microsoft.com/office/drawing/2014/main" id="{0CE3C8F5-53A0-B918-7F99-EE46EA1C41D5}"/>
               </a:ext>
             </a:extLst>
           </p:cNvPr>
@@ -5778,7 +5692,7 @@
           <p:cNvPr id="10" name="TextBox 9">
             <a:extLst>
               <a:ext uri="{FF2B5EF4-FFF2-40B4-BE49-F238E27FC236}">
-                <a16:creationId xmlns:a16="http://schemas.microsoft.com/office/drawing/2014/main" id="{9D965C10-BA05-58CF-BE30-C73E07281A7F}"/>
+                <a16:creationId xmlns:a16="http://schemas.microsoft.com/office/drawing/2014/main" id="{05AB4EC6-DF65-9651-6879-704B9B7FEB13}"/>
               </a:ext>
             </a:extLst>
           </p:cNvPr>
@@ -5829,7 +5743,7 @@
           <p:cNvPr id="11" name="Rectangle: Rounded Corners 10">
             <a:extLst>
               <a:ext uri="{FF2B5EF4-FFF2-40B4-BE49-F238E27FC236}">
-                <a16:creationId xmlns:a16="http://schemas.microsoft.com/office/drawing/2014/main" id="{C69004BC-9127-6A1C-BC27-ABB246171084}"/>
+                <a16:creationId xmlns:a16="http://schemas.microsoft.com/office/drawing/2014/main" id="{CDC1F43E-657D-0E8E-5C4D-5F90FF44FBA7}"/>
               </a:ext>
             </a:extLst>
           </p:cNvPr>
@@ -5969,7 +5883,7 @@
           <p:cNvPr id="2" name="Rectangle: Rounded Corners 1">
             <a:extLst>
               <a:ext uri="{FF2B5EF4-FFF2-40B4-BE49-F238E27FC236}">
-                <a16:creationId xmlns:a16="http://schemas.microsoft.com/office/drawing/2014/main" id="{3887586D-5EBE-022E-F4E9-1A8FC5F05C94}"/>
+                <a16:creationId xmlns:a16="http://schemas.microsoft.com/office/drawing/2014/main" id="{43B8C349-31EC-A3EA-848C-B35B387D363C}"/>
               </a:ext>
             </a:extLst>
           </p:cNvPr>
@@ -6067,7 +5981,7 @@
           <p:cNvPr id="3" name="Rectangle: Rounded Corners 2">
             <a:extLst>
               <a:ext uri="{FF2B5EF4-FFF2-40B4-BE49-F238E27FC236}">
-                <a16:creationId xmlns:a16="http://schemas.microsoft.com/office/drawing/2014/main" id="{39ACCFBF-36DA-0AA3-2C24-4E2B94E0DF87}"/>
+                <a16:creationId xmlns:a16="http://schemas.microsoft.com/office/drawing/2014/main" id="{D2368374-AF30-5585-1DC8-8CEB7E5212BE}"/>
               </a:ext>
             </a:extLst>
           </p:cNvPr>
@@ -6165,7 +6079,7 @@
           <p:cNvPr id="5" name="Rectangle: Rounded Corners 4">
             <a:extLst>
               <a:ext uri="{FF2B5EF4-FFF2-40B4-BE49-F238E27FC236}">
-                <a16:creationId xmlns:a16="http://schemas.microsoft.com/office/drawing/2014/main" id="{3CFC1DA4-19FD-0857-F305-A100CFACF841}"/>
+                <a16:creationId xmlns:a16="http://schemas.microsoft.com/office/drawing/2014/main" id="{8228924D-8F12-2BE4-9CE3-08CF33319F5F}"/>
               </a:ext>
             </a:extLst>
           </p:cNvPr>
@@ -6329,7 +6243,7 @@
           <p:cNvPr id="2" name="Rectangle: Rounded Corners 1">
             <a:extLst>
               <a:ext uri="{FF2B5EF4-FFF2-40B4-BE49-F238E27FC236}">
-                <a16:creationId xmlns:a16="http://schemas.microsoft.com/office/drawing/2014/main" id="{6EE319BF-02E2-3E46-009B-42F128995818}"/>
+                <a16:creationId xmlns:a16="http://schemas.microsoft.com/office/drawing/2014/main" id="{475B776A-3271-1BB9-9AEC-13E71C0EBD31}"/>
               </a:ext>
             </a:extLst>
           </p:cNvPr>
@@ -6490,7 +6404,7 @@
           <p:cNvPr id="3" name="Rectangle: Rounded Corners 2">
             <a:extLst>
               <a:ext uri="{FF2B5EF4-FFF2-40B4-BE49-F238E27FC236}">
-                <a16:creationId xmlns:a16="http://schemas.microsoft.com/office/drawing/2014/main" id="{3E0826AF-08C0-77EF-90FC-958E2577842B}"/>
+                <a16:creationId xmlns:a16="http://schemas.microsoft.com/office/drawing/2014/main" id="{09EFA5F1-2A84-FA17-6E69-C0D809891D5E}"/>
               </a:ext>
             </a:extLst>
           </p:cNvPr>
@@ -6651,7 +6565,7 @@
           <p:cNvPr id="5" name="Rectangle: Rounded Corners 4">
             <a:extLst>
               <a:ext uri="{FF2B5EF4-FFF2-40B4-BE49-F238E27FC236}">
-                <a16:creationId xmlns:a16="http://schemas.microsoft.com/office/drawing/2014/main" id="{C7C62CC1-9FD6-CFC1-6835-8E6AE591A7EB}"/>
+                <a16:creationId xmlns:a16="http://schemas.microsoft.com/office/drawing/2014/main" id="{0DFA4DC7-F68E-64B4-426D-D5BB6544BE9D}"/>
               </a:ext>
             </a:extLst>
           </p:cNvPr>

</xml_diff>

<commit_message>
feat: enhance offline resilience, clean test imports, and update presentation links
</commit_message>
<xml_diff>
--- a/Team_Phoenix_INIT26_Presentation.pptx
+++ b/Team_Phoenix_INIT26_Presentation.pptx
@@ -3520,7 +3520,7 @@
           <p:cNvPr id="12" name="Rectangle: Rounded Corners 11">
             <a:extLst>
               <a:ext uri="{FF2B5EF4-FFF2-40B4-BE49-F238E27FC236}">
-                <a16:creationId xmlns:a16="http://schemas.microsoft.com/office/drawing/2014/main" id="{7626922B-8AB6-3549-8DC8-BCAA87C73D44}"/>
+                <a16:creationId xmlns:a16="http://schemas.microsoft.com/office/drawing/2014/main" id="{E17F563A-4736-37D6-B170-0E0F603C3A35}"/>
               </a:ext>
             </a:extLst>
           </p:cNvPr>
@@ -3648,7 +3648,7 @@
           <p:cNvPr id="2" name="Rectangle: Rounded Corners 1">
             <a:extLst>
               <a:ext uri="{FF2B5EF4-FFF2-40B4-BE49-F238E27FC236}">
-                <a16:creationId xmlns:a16="http://schemas.microsoft.com/office/drawing/2014/main" id="{72C4742E-A88E-62A3-DEEA-20E15A8B313B}"/>
+                <a16:creationId xmlns:a16="http://schemas.microsoft.com/office/drawing/2014/main" id="{D6A930CA-6C98-1545-CDE8-BE9238C8F512}"/>
               </a:ext>
             </a:extLst>
           </p:cNvPr>
@@ -3887,7 +3887,7 @@
           <p:cNvPr id="2" name="Rectangle: Rounded Corners 1">
             <a:extLst>
               <a:ext uri="{FF2B5EF4-FFF2-40B4-BE49-F238E27FC236}">
-                <a16:creationId xmlns:a16="http://schemas.microsoft.com/office/drawing/2014/main" id="{089586ED-C921-E2B2-1E68-403551735BC3}"/>
+                <a16:creationId xmlns:a16="http://schemas.microsoft.com/office/drawing/2014/main" id="{A192A530-982A-463B-6B63-143BAFEE717E}"/>
               </a:ext>
             </a:extLst>
           </p:cNvPr>
@@ -4033,7 +4033,7 @@
           <p:cNvPr id="3" name="Rectangle: Rounded Corners 2">
             <a:extLst>
               <a:ext uri="{FF2B5EF4-FFF2-40B4-BE49-F238E27FC236}">
-                <a16:creationId xmlns:a16="http://schemas.microsoft.com/office/drawing/2014/main" id="{1212EF2E-A0F9-4769-F5FE-9DFB928064B8}"/>
+                <a16:creationId xmlns:a16="http://schemas.microsoft.com/office/drawing/2014/main" id="{D0CBF521-24CA-0244-6A52-FB2C4D5D1560}"/>
               </a:ext>
             </a:extLst>
           </p:cNvPr>
@@ -4179,7 +4179,7 @@
           <p:cNvPr id="5" name="Rectangle: Rounded Corners 4">
             <a:extLst>
               <a:ext uri="{FF2B5EF4-FFF2-40B4-BE49-F238E27FC236}">
-                <a16:creationId xmlns:a16="http://schemas.microsoft.com/office/drawing/2014/main" id="{F8D7B31E-A603-87EC-6F2C-6724108CC596}"/>
+                <a16:creationId xmlns:a16="http://schemas.microsoft.com/office/drawing/2014/main" id="{C8DEBF11-021F-D05E-37A1-D3942213B898}"/>
               </a:ext>
             </a:extLst>
           </p:cNvPr>
@@ -4391,7 +4391,7 @@
           <p:cNvPr id="2" name="Rectangle: Rounded Corners 1">
             <a:extLst>
               <a:ext uri="{FF2B5EF4-FFF2-40B4-BE49-F238E27FC236}">
-                <a16:creationId xmlns:a16="http://schemas.microsoft.com/office/drawing/2014/main" id="{4779C81C-E4DB-768B-1BD3-9430539B0736}"/>
+                <a16:creationId xmlns:a16="http://schemas.microsoft.com/office/drawing/2014/main" id="{8B7E79E6-31D9-5CD5-5A71-05D5D80FFFE5}"/>
               </a:ext>
             </a:extLst>
           </p:cNvPr>
@@ -4501,7 +4501,7 @@
           <p:cNvPr id="3" name="Rectangle: Rounded Corners 2">
             <a:extLst>
               <a:ext uri="{FF2B5EF4-FFF2-40B4-BE49-F238E27FC236}">
-                <a16:creationId xmlns:a16="http://schemas.microsoft.com/office/drawing/2014/main" id="{9A163D25-F3A6-3F1D-F5C0-AA214AF5C195}"/>
+                <a16:creationId xmlns:a16="http://schemas.microsoft.com/office/drawing/2014/main" id="{BF9E5E57-9C35-9ABC-8FC7-FF44536E9A84}"/>
               </a:ext>
             </a:extLst>
           </p:cNvPr>
@@ -4611,7 +4611,7 @@
           <p:cNvPr id="5" name="Rectangle: Rounded Corners 4">
             <a:extLst>
               <a:ext uri="{FF2B5EF4-FFF2-40B4-BE49-F238E27FC236}">
-                <a16:creationId xmlns:a16="http://schemas.microsoft.com/office/drawing/2014/main" id="{7A76F398-5352-4055-D316-F0E6DA9F2C73}"/>
+                <a16:creationId xmlns:a16="http://schemas.microsoft.com/office/drawing/2014/main" id="{709464AC-E2E7-98F9-193C-FD3615161B4C}"/>
               </a:ext>
             </a:extLst>
           </p:cNvPr>
@@ -4721,7 +4721,7 @@
           <p:cNvPr id="6" name="Rectangle: Rounded Corners 5">
             <a:extLst>
               <a:ext uri="{FF2B5EF4-FFF2-40B4-BE49-F238E27FC236}">
-                <a16:creationId xmlns:a16="http://schemas.microsoft.com/office/drawing/2014/main" id="{D21F9FAE-BD49-88FD-899A-0973B37D1190}"/>
+                <a16:creationId xmlns:a16="http://schemas.microsoft.com/office/drawing/2014/main" id="{75527663-180A-0B3B-E34D-51BA72A80378}"/>
               </a:ext>
             </a:extLst>
           </p:cNvPr>
@@ -4897,7 +4897,7 @@
           <p:cNvPr id="2" name="Rectangle: Rounded Corners 1">
             <a:extLst>
               <a:ext uri="{FF2B5EF4-FFF2-40B4-BE49-F238E27FC236}">
-                <a16:creationId xmlns:a16="http://schemas.microsoft.com/office/drawing/2014/main" id="{DC9FD2A8-8A14-F19F-0FC1-EF7BAAA14BED}"/>
+                <a16:creationId xmlns:a16="http://schemas.microsoft.com/office/drawing/2014/main" id="{3D3AB14B-2FE2-E842-EC38-E3A04232CBEF}"/>
               </a:ext>
             </a:extLst>
           </p:cNvPr>
@@ -4980,7 +4980,7 @@
           <p:cNvPr id="3" name="Rectangle: Rounded Corners 2">
             <a:extLst>
               <a:ext uri="{FF2B5EF4-FFF2-40B4-BE49-F238E27FC236}">
-                <a16:creationId xmlns:a16="http://schemas.microsoft.com/office/drawing/2014/main" id="{62506BBB-2039-037C-6CB6-E3E4E3BBA118}"/>
+                <a16:creationId xmlns:a16="http://schemas.microsoft.com/office/drawing/2014/main" id="{48E46331-396D-99B3-20A3-B780331B4BED}"/>
               </a:ext>
             </a:extLst>
           </p:cNvPr>
@@ -5063,7 +5063,7 @@
           <p:cNvPr id="5" name="Rectangle: Rounded Corners 4">
             <a:extLst>
               <a:ext uri="{FF2B5EF4-FFF2-40B4-BE49-F238E27FC236}">
-                <a16:creationId xmlns:a16="http://schemas.microsoft.com/office/drawing/2014/main" id="{7485681F-8805-977E-718A-467DE8AEE75A}"/>
+                <a16:creationId xmlns:a16="http://schemas.microsoft.com/office/drawing/2014/main" id="{CCDF1271-9C5C-93AF-956E-6E1E7C6BD42D}"/>
               </a:ext>
             </a:extLst>
           </p:cNvPr>
@@ -5146,7 +5146,7 @@
           <p:cNvPr id="6" name="Rectangle: Rounded Corners 5">
             <a:extLst>
               <a:ext uri="{FF2B5EF4-FFF2-40B4-BE49-F238E27FC236}">
-                <a16:creationId xmlns:a16="http://schemas.microsoft.com/office/drawing/2014/main" id="{8DCD9808-15B7-1054-0B76-5AC4ED87E22C}"/>
+                <a16:creationId xmlns:a16="http://schemas.microsoft.com/office/drawing/2014/main" id="{9CA66175-2463-7B15-2715-6A81FB3CBE40}"/>
               </a:ext>
             </a:extLst>
           </p:cNvPr>
@@ -5229,7 +5229,7 @@
           <p:cNvPr id="7" name="Rectangle: Rounded Corners 6">
             <a:extLst>
               <a:ext uri="{FF2B5EF4-FFF2-40B4-BE49-F238E27FC236}">
-                <a16:creationId xmlns:a16="http://schemas.microsoft.com/office/drawing/2014/main" id="{BD934FA4-53FE-441F-74F1-1C804A0212F0}"/>
+                <a16:creationId xmlns:a16="http://schemas.microsoft.com/office/drawing/2014/main" id="{68D70F8D-F5E1-8015-956A-384865F02C9E}"/>
               </a:ext>
             </a:extLst>
           </p:cNvPr>
@@ -5312,7 +5312,7 @@
           <p:cNvPr id="8" name="Rectangle: Rounded Corners 7">
             <a:extLst>
               <a:ext uri="{FF2B5EF4-FFF2-40B4-BE49-F238E27FC236}">
-                <a16:creationId xmlns:a16="http://schemas.microsoft.com/office/drawing/2014/main" id="{F17496D9-2AF6-DDD6-0FCB-E8E918D8A68F}"/>
+                <a16:creationId xmlns:a16="http://schemas.microsoft.com/office/drawing/2014/main" id="{EFC83EB7-A69E-0ACB-CB47-D09B79B5A046}"/>
               </a:ext>
             </a:extLst>
           </p:cNvPr>
@@ -5461,7 +5461,7 @@
           <p:cNvPr id="2" name="Rectangle: Rounded Corners 1">
             <a:extLst>
               <a:ext uri="{FF2B5EF4-FFF2-40B4-BE49-F238E27FC236}">
-                <a16:creationId xmlns:a16="http://schemas.microsoft.com/office/drawing/2014/main" id="{2D2B51CC-07E4-7F9F-BB7D-279D8B9B1C4F}"/>
+                <a16:creationId xmlns:a16="http://schemas.microsoft.com/office/drawing/2014/main" id="{77060A66-6286-A6AF-B687-C14C34049581}"/>
               </a:ext>
             </a:extLst>
           </p:cNvPr>
@@ -5515,7 +5515,7 @@
           <p:cNvPr id="5" name="Picture 4">
             <a:extLst>
               <a:ext uri="{FF2B5EF4-FFF2-40B4-BE49-F238E27FC236}">
-                <a16:creationId xmlns:a16="http://schemas.microsoft.com/office/drawing/2014/main" id="{8B53CA76-E90C-E4C0-6D0F-84AF8F1FDFF0}"/>
+                <a16:creationId xmlns:a16="http://schemas.microsoft.com/office/drawing/2014/main" id="{18058EE0-1423-D7C2-F0D5-1C9B7BE81A96}"/>
               </a:ext>
             </a:extLst>
           </p:cNvPr>
@@ -5551,7 +5551,7 @@
           <p:cNvPr id="6" name="TextBox 5">
             <a:extLst>
               <a:ext uri="{FF2B5EF4-FFF2-40B4-BE49-F238E27FC236}">
-                <a16:creationId xmlns:a16="http://schemas.microsoft.com/office/drawing/2014/main" id="{88037A8D-50BC-EE1D-6107-F19E0837CD86}"/>
+                <a16:creationId xmlns:a16="http://schemas.microsoft.com/office/drawing/2014/main" id="{DD273FCC-5394-E39B-BEBF-C6803BB2D86A}"/>
               </a:ext>
             </a:extLst>
           </p:cNvPr>
@@ -5602,7 +5602,7 @@
           <p:cNvPr id="7" name="Rectangle: Rounded Corners 6">
             <a:extLst>
               <a:ext uri="{FF2B5EF4-FFF2-40B4-BE49-F238E27FC236}">
-                <a16:creationId xmlns:a16="http://schemas.microsoft.com/office/drawing/2014/main" id="{2E0D7508-BF85-063F-F2C2-B02CE6D5D665}"/>
+                <a16:creationId xmlns:a16="http://schemas.microsoft.com/office/drawing/2014/main" id="{D190DA65-F694-2FF5-6E20-E3BB3AC50BDE}"/>
               </a:ext>
             </a:extLst>
           </p:cNvPr>
@@ -5656,7 +5656,7 @@
           <p:cNvPr id="9" name="Picture 8">
             <a:extLst>
               <a:ext uri="{FF2B5EF4-FFF2-40B4-BE49-F238E27FC236}">
-                <a16:creationId xmlns:a16="http://schemas.microsoft.com/office/drawing/2014/main" id="{0CE3C8F5-53A0-B918-7F99-EE46EA1C41D5}"/>
+                <a16:creationId xmlns:a16="http://schemas.microsoft.com/office/drawing/2014/main" id="{551E255F-F1BE-EA11-AD0E-5DC05966F60A}"/>
               </a:ext>
             </a:extLst>
           </p:cNvPr>
@@ -5692,7 +5692,7 @@
           <p:cNvPr id="10" name="TextBox 9">
             <a:extLst>
               <a:ext uri="{FF2B5EF4-FFF2-40B4-BE49-F238E27FC236}">
-                <a16:creationId xmlns:a16="http://schemas.microsoft.com/office/drawing/2014/main" id="{05AB4EC6-DF65-9651-6879-704B9B7FEB13}"/>
+                <a16:creationId xmlns:a16="http://schemas.microsoft.com/office/drawing/2014/main" id="{DE0D7997-6453-1848-3F2D-39B035C69A1A}"/>
               </a:ext>
             </a:extLst>
           </p:cNvPr>
@@ -5743,7 +5743,7 @@
           <p:cNvPr id="11" name="Rectangle: Rounded Corners 10">
             <a:extLst>
               <a:ext uri="{FF2B5EF4-FFF2-40B4-BE49-F238E27FC236}">
-                <a16:creationId xmlns:a16="http://schemas.microsoft.com/office/drawing/2014/main" id="{CDC1F43E-657D-0E8E-5C4D-5F90FF44FBA7}"/>
+                <a16:creationId xmlns:a16="http://schemas.microsoft.com/office/drawing/2014/main" id="{3CFC6DFF-AA2E-2DD4-19B6-A668295E2887}"/>
               </a:ext>
             </a:extLst>
           </p:cNvPr>
@@ -5883,7 +5883,7 @@
           <p:cNvPr id="2" name="Rectangle: Rounded Corners 1">
             <a:extLst>
               <a:ext uri="{FF2B5EF4-FFF2-40B4-BE49-F238E27FC236}">
-                <a16:creationId xmlns:a16="http://schemas.microsoft.com/office/drawing/2014/main" id="{43B8C349-31EC-A3EA-848C-B35B387D363C}"/>
+                <a16:creationId xmlns:a16="http://schemas.microsoft.com/office/drawing/2014/main" id="{78798578-FC5C-377F-0E76-8D93AAFCB353}"/>
               </a:ext>
             </a:extLst>
           </p:cNvPr>
@@ -5981,7 +5981,7 @@
           <p:cNvPr id="3" name="Rectangle: Rounded Corners 2">
             <a:extLst>
               <a:ext uri="{FF2B5EF4-FFF2-40B4-BE49-F238E27FC236}">
-                <a16:creationId xmlns:a16="http://schemas.microsoft.com/office/drawing/2014/main" id="{D2368374-AF30-5585-1DC8-8CEB7E5212BE}"/>
+                <a16:creationId xmlns:a16="http://schemas.microsoft.com/office/drawing/2014/main" id="{42DB3F04-153A-D773-4F81-AA63326448AD}"/>
               </a:ext>
             </a:extLst>
           </p:cNvPr>
@@ -6079,7 +6079,7 @@
           <p:cNvPr id="5" name="Rectangle: Rounded Corners 4">
             <a:extLst>
               <a:ext uri="{FF2B5EF4-FFF2-40B4-BE49-F238E27FC236}">
-                <a16:creationId xmlns:a16="http://schemas.microsoft.com/office/drawing/2014/main" id="{8228924D-8F12-2BE4-9CE3-08CF33319F5F}"/>
+                <a16:creationId xmlns:a16="http://schemas.microsoft.com/office/drawing/2014/main" id="{3FB84291-8E18-4FC8-72DA-494475E77EBD}"/>
               </a:ext>
             </a:extLst>
           </p:cNvPr>
@@ -6243,7 +6243,7 @@
           <p:cNvPr id="2" name="Rectangle: Rounded Corners 1">
             <a:extLst>
               <a:ext uri="{FF2B5EF4-FFF2-40B4-BE49-F238E27FC236}">
-                <a16:creationId xmlns:a16="http://schemas.microsoft.com/office/drawing/2014/main" id="{475B776A-3271-1BB9-9AEC-13E71C0EBD31}"/>
+                <a16:creationId xmlns:a16="http://schemas.microsoft.com/office/drawing/2014/main" id="{0BED8322-7BCD-8D36-F008-F068C358A8B7}"/>
               </a:ext>
             </a:extLst>
           </p:cNvPr>
@@ -6252,14 +6252,120 @@
         </p:nvSpPr>
         <p:spPr>
           <a:xfrm>
-            <a:off x="1460500" y="1778000"/>
-            <a:ext cx="5016500" cy="7493000"/>
+            <a:off x="1460500" y="1905000"/>
+            <a:ext cx="7683500" cy="7239000"/>
           </a:xfrm>
           <a:prstGeom prst="roundRect">
             <a:avLst/>
           </a:prstGeom>
           <a:solidFill>
             <a:srgbClr val="111827"/>
+          </a:solidFill>
+          <a:ln w="25400">
+            <a:solidFill>
+              <a:srgbClr val="22C55E"/>
+            </a:solidFill>
+          </a:ln>
+        </p:spPr>
+        <p:style>
+          <a:lnRef idx="2">
+            <a:schemeClr val="accent1">
+              <a:shade val="15000"/>
+            </a:schemeClr>
+          </a:lnRef>
+          <a:fillRef idx="1">
+            <a:schemeClr val="accent1"/>
+          </a:fillRef>
+          <a:effectRef idx="0">
+            <a:schemeClr val="accent1"/>
+          </a:effectRef>
+          <a:fontRef idx="minor">
+            <a:schemeClr val="lt1"/>
+          </a:fontRef>
+        </p:style>
+        <p:txBody>
+          <a:bodyPr rtlCol="0" anchor="ctr"/>
+          <a:lstStyle/>
+          <a:p>
+            <a:pPr algn="ctr"/>
+            <a:endParaRPr lang="en-US"/>
+          </a:p>
+        </p:txBody>
+      </p:sp>
+      <p:sp>
+        <p:nvSpPr>
+          <p:cNvPr id="3" name="TextBox 2">
+            <a:extLst>
+              <a:ext uri="{FF2B5EF4-FFF2-40B4-BE49-F238E27FC236}">
+                <a16:creationId xmlns:a16="http://schemas.microsoft.com/office/drawing/2014/main" id="{99782BE1-5F6A-2E44-28A1-E93E47F30566}"/>
+              </a:ext>
+            </a:extLst>
+          </p:cNvPr>
+          <p:cNvSpPr txBox="1"/>
+          <p:nvPr/>
+        </p:nvSpPr>
+        <p:spPr>
+          <a:xfrm>
+            <a:off x="1841500" y="2222500"/>
+            <a:ext cx="6921500" cy="669414"/>
+          </a:xfrm>
+          <a:prstGeom prst="rect">
+            <a:avLst/>
+          </a:prstGeom>
+          <a:noFill/>
+        </p:spPr>
+        <p:txBody>
+          <a:bodyPr vert="horz" rtlCol="0">
+            <a:spAutoFit/>
+          </a:bodyPr>
+          <a:lstStyle/>
+          <a:p>
+            <a:r>
+              <a:rPr lang="en-US" sz="2400" b="1">
+                <a:solidFill>
+                  <a:srgbClr val="22C55E"/>
+                </a:solidFill>
+                <a:latin typeface="Antonio Bold" panose="020B0604020202020204" charset="0"/>
+              </a:rPr>
+              <a:t>LIVE DEMO PLATFORM</a:t>
+            </a:r>
+          </a:p>
+          <a:p>
+            <a:r>
+              <a:rPr lang="en-US" sz="1350" b="1">
+                <a:solidFill>
+                  <a:srgbClr val="06B6D4"/>
+                </a:solidFill>
+                <a:latin typeface="Segoe UI" panose="020B0502040204020203" pitchFamily="34" charset="0"/>
+              </a:rPr>
+              <a:t>Production Security Operations Center (SOC) on Vercel</a:t>
+            </a:r>
+          </a:p>
+        </p:txBody>
+      </p:sp>
+      <p:sp>
+        <p:nvSpPr>
+          <p:cNvPr id="5" name="Rectangle: Rounded Corners 4">
+            <a:hlinkClick r:id="rId2"/>
+            <a:extLst>
+              <a:ext uri="{FF2B5EF4-FFF2-40B4-BE49-F238E27FC236}">
+                <a16:creationId xmlns:a16="http://schemas.microsoft.com/office/drawing/2014/main" id="{3026D008-2D1D-1733-DED1-70919402F2FB}"/>
+              </a:ext>
+            </a:extLst>
+          </p:cNvPr>
+          <p:cNvSpPr/>
+          <p:nvPr/>
+        </p:nvSpPr>
+        <p:spPr>
+          <a:xfrm>
+            <a:off x="1841500" y="3175000"/>
+            <a:ext cx="6921500" cy="635000"/>
+          </a:xfrm>
+          <a:prstGeom prst="roundRect">
+            <a:avLst/>
+          </a:prstGeom>
+          <a:solidFill>
+            <a:srgbClr val="0F172A"/>
           </a:solidFill>
           <a:ln w="19050">
             <a:solidFill>
@@ -6284,23 +6390,62 @@
           </a:fontRef>
         </p:style>
         <p:txBody>
-          <a:bodyPr lIns="317500" tIns="317500" rIns="317500" rtlCol="0" anchor="ctr"/>
-          <a:lstStyle/>
-          <a:p>
-            <a:pPr algn="ctr"/>
-            <a:r>
-              <a:rPr lang="en-US" b="1">
+          <a:bodyPr rtlCol="0" anchor="ctr"/>
+          <a:lstStyle/>
+          <a:p>
+            <a:pPr algn="ctr"/>
+            <a:r>
+              <a:rPr lang="en-US" sz="1600" b="1">
+                <a:solidFill>
+                  <a:srgbClr val="FFFFFF"/>
+                </a:solidFill>
+                <a:latin typeface="Segoe UI" panose="020B0502040204020203" pitchFamily="34" charset="0"/>
+              </a:rPr>
+              <a:t>https://apisentinel-psi.vercel.app</a:t>
+            </a:r>
+          </a:p>
+        </p:txBody>
+      </p:sp>
+      <p:sp>
+        <p:nvSpPr>
+          <p:cNvPr id="6" name="TextBox 5">
+            <a:extLst>
+              <a:ext uri="{FF2B5EF4-FFF2-40B4-BE49-F238E27FC236}">
+                <a16:creationId xmlns:a16="http://schemas.microsoft.com/office/drawing/2014/main" id="{9133F72B-CE81-6BF1-A96A-B9D8297AAC63}"/>
+              </a:ext>
+            </a:extLst>
+          </p:cNvPr>
+          <p:cNvSpPr txBox="1"/>
+          <p:nvPr/>
+        </p:nvSpPr>
+        <p:spPr>
+          <a:xfrm>
+            <a:off x="1841500" y="4000500"/>
+            <a:ext cx="6921500" cy="3254737"/>
+          </a:xfrm>
+          <a:prstGeom prst="rect">
+            <a:avLst/>
+          </a:prstGeom>
+          <a:noFill/>
+        </p:spPr>
+        <p:txBody>
+          <a:bodyPr vert="horz" rtlCol="0">
+            <a:spAutoFit/>
+          </a:bodyPr>
+          <a:lstStyle/>
+          <a:p>
+            <a:r>
+              <a:rPr lang="en-US" sz="1500" b="1">
                 <a:solidFill>
                   <a:srgbClr val="22C55E"/>
                 </a:solidFill>
                 <a:latin typeface="Antonio Bold" panose="020B0604020202020204" charset="0"/>
               </a:rPr>
-              <a:t>INDUSTRY STANDARDS &amp; RESEARCH</a:t>
-            </a:r>
-          </a:p>
-          <a:p>
-            <a:pPr algn="ctr"/>
-            <a:endParaRPr lang="en-US" b="1">
+              <a:t>PLATFORM CAPABILITIES:</a:t>
+            </a:r>
+          </a:p>
+          <a:p>
+            <a:endParaRPr lang="en-US" sz="1500" b="1">
               <a:solidFill>
                 <a:srgbClr val="22C55E"/>
               </a:solidFill>
@@ -6308,7 +6453,6 @@
             </a:endParaRPr>
           </a:p>
           <a:p>
-            <a:pPr algn="ctr"/>
             <a:r>
               <a:rPr lang="en-US" sz="1350">
                 <a:solidFill>
@@ -6316,23 +6460,10 @@
                 </a:solidFill>
                 <a:latin typeface="Segoe UI" panose="020B0502040204020203" pitchFamily="34" charset="0"/>
               </a:rPr>
-              <a:t>- OWASP API Security Top 10 (2023)</a:t>
-            </a:r>
-          </a:p>
-          <a:p>
-            <a:pPr algn="ctr"/>
-            <a:r>
-              <a:rPr lang="en-US" sz="1350">
-                <a:solidFill>
-                  <a:srgbClr val="E2E8F0"/>
-                </a:solidFill>
-                <a:latin typeface="Segoe UI" panose="020B0502040204020203" pitchFamily="34" charset="0"/>
-              </a:rPr>
-              <a:t>  Vulnerability standards covering BOLA, Broken Authentication, Object Property Level Authorization, and Unrestricted Resource Consumption.</a:t>
-            </a:r>
-          </a:p>
-          <a:p>
-            <a:pPr algn="ctr"/>
+              <a:t>- Real-Time SOC Dashboard: Instant visibility into active threats, request verdicts, risk scores, and traffic health.</a:t>
+            </a:r>
+          </a:p>
+          <a:p>
             <a:endParaRPr lang="en-US" sz="1350">
               <a:solidFill>
                 <a:srgbClr val="E2E8F0"/>
@@ -6341,7 +6472,6 @@
             </a:endParaRPr>
           </a:p>
           <a:p>
-            <a:pPr algn="ctr"/>
             <a:r>
               <a:rPr lang="en-US" sz="1350">
                 <a:solidFill>
@@ -6349,23 +6479,10 @@
                 </a:solidFill>
                 <a:latin typeface="Segoe UI" panose="020B0502040204020203" pitchFamily="34" charset="0"/>
               </a:rPr>
-              <a:t>- NIST Special Publication 800-207</a:t>
-            </a:r>
-          </a:p>
-          <a:p>
-            <a:pPr algn="ctr"/>
-            <a:r>
-              <a:rPr lang="en-US" sz="1350">
-                <a:solidFill>
-                  <a:srgbClr val="E2E8F0"/>
-                </a:solidFill>
-                <a:latin typeface="Segoe UI" panose="020B0502040204020203" pitchFamily="34" charset="0"/>
-              </a:rPr>
-              <a:t>  Zero Trust Architecture guidelines emphasizing per-request authentication, dynamic policy evaluation, and perimeter isolation.</a:t>
-            </a:r>
-          </a:p>
-          <a:p>
-            <a:pPr algn="ctr"/>
+              <a:t>- Autonomous Policy Mitigation: Dynamic zero-trust blocking (HTTP 403) and rate limiting (HTTP 429).</a:t>
+            </a:r>
+          </a:p>
+          <a:p>
             <a:endParaRPr lang="en-US" sz="1350">
               <a:solidFill>
                 <a:srgbClr val="E2E8F0"/>
@@ -6374,7 +6491,6 @@
             </a:endParaRPr>
           </a:p>
           <a:p>
-            <a:pPr algn="ctr"/>
             <a:r>
               <a:rPr lang="en-US" sz="1350">
                 <a:solidFill>
@@ -6382,11 +6498,18 @@
                 </a:solidFill>
                 <a:latin typeface="Segoe UI" panose="020B0502040204020203" pitchFamily="34" charset="0"/>
               </a:rPr>
-              <a:t>- MITRE ATT&amp;CK Framework</a:t>
-            </a:r>
-          </a:p>
-          <a:p>
-            <a:pPr algn="ctr"/>
+              <a:t>- Interactive Attack Simulator: Test live OWASP payloads (SQLi, IDOR/BOLA, Brute Force) against protected endpoints.</a:t>
+            </a:r>
+          </a:p>
+          <a:p>
+            <a:endParaRPr lang="en-US" sz="1350">
+              <a:solidFill>
+                <a:srgbClr val="E2E8F0"/>
+              </a:solidFill>
+              <a:latin typeface="Segoe UI" panose="020B0502040204020203" pitchFamily="34" charset="0"/>
+            </a:endParaRPr>
+          </a:p>
+          <a:p>
             <a:r>
               <a:rPr lang="en-US" sz="1350">
                 <a:solidFill>
@@ -6394,17 +6517,36 @@
                 </a:solidFill>
                 <a:latin typeface="Segoe UI" panose="020B0502040204020203" pitchFamily="34" charset="0"/>
               </a:rPr>
-              <a:t>  Tactics, Techniques, and Procedures (TTPs) for Web Application and API exploitation vectors.</a:t>
-            </a:r>
-          </a:p>
-        </p:txBody>
-      </p:sp>
-      <p:sp>
-        <p:nvSpPr>
-          <p:cNvPr id="3" name="Rectangle: Rounded Corners 2">
+              <a:t>- Forensic Request Inspector: Deep inspection of headers, masked credentials, and cached payload bodies.</a:t>
+            </a:r>
+          </a:p>
+          <a:p>
+            <a:endParaRPr lang="en-US" sz="1350">
+              <a:solidFill>
+                <a:srgbClr val="E2E8F0"/>
+              </a:solidFill>
+              <a:latin typeface="Segoe UI" panose="020B0502040204020203" pitchFamily="34" charset="0"/>
+            </a:endParaRPr>
+          </a:p>
+          <a:p>
+            <a:r>
+              <a:rPr lang="en-US" sz="1350">
+                <a:solidFill>
+                  <a:srgbClr val="E2E8F0"/>
+                </a:solidFill>
+                <a:latin typeface="Segoe UI" panose="020B0502040204020203" pitchFamily="34" charset="0"/>
+              </a:rPr>
+              <a:t>- Cloud Deployment: High-availability edge hosting on Vercel.</a:t>
+            </a:r>
+          </a:p>
+        </p:txBody>
+      </p:sp>
+      <p:sp>
+        <p:nvSpPr>
+          <p:cNvPr id="7" name="Rectangle: Rounded Corners 6">
             <a:extLst>
               <a:ext uri="{FF2B5EF4-FFF2-40B4-BE49-F238E27FC236}">
-                <a16:creationId xmlns:a16="http://schemas.microsoft.com/office/drawing/2014/main" id="{09EFA5F1-2A84-FA17-6E69-C0D809891D5E}"/>
+                <a16:creationId xmlns:a16="http://schemas.microsoft.com/office/drawing/2014/main" id="{7CCD105B-DFB8-D945-FAFB-532E30601A11}"/>
               </a:ext>
             </a:extLst>
           </p:cNvPr>
@@ -6413,14 +6555,126 @@
         </p:nvSpPr>
         <p:spPr>
           <a:xfrm>
-            <a:off x="6921500" y="1778000"/>
-            <a:ext cx="5016500" cy="7493000"/>
+            <a:off x="9715500" y="1905000"/>
+            <a:ext cx="7683500" cy="7239000"/>
           </a:xfrm>
           <a:prstGeom prst="roundRect">
             <a:avLst/>
           </a:prstGeom>
           <a:solidFill>
             <a:srgbClr val="111827"/>
+          </a:solidFill>
+          <a:ln w="25400">
+            <a:solidFill>
+              <a:srgbClr val="06B6D4"/>
+            </a:solidFill>
+          </a:ln>
+        </p:spPr>
+        <p:style>
+          <a:lnRef idx="2">
+            <a:schemeClr val="accent1">
+              <a:shade val="15000"/>
+            </a:schemeClr>
+          </a:lnRef>
+          <a:fillRef idx="1">
+            <a:schemeClr val="accent1"/>
+          </a:fillRef>
+          <a:effectRef idx="0">
+            <a:schemeClr val="accent1"/>
+          </a:effectRef>
+          <a:fontRef idx="minor">
+            <a:schemeClr val="lt1"/>
+          </a:fontRef>
+        </p:style>
+        <p:txBody>
+          <a:bodyPr rtlCol="0" anchor="ctr"/>
+          <a:lstStyle/>
+          <a:p>
+            <a:pPr algn="ctr"/>
+            <a:endParaRPr lang="en-US"/>
+          </a:p>
+        </p:txBody>
+      </p:sp>
+      <p:sp>
+        <p:nvSpPr>
+          <p:cNvPr id="8" name="TextBox 7">
+            <a:extLst>
+              <a:ext uri="{FF2B5EF4-FFF2-40B4-BE49-F238E27FC236}">
+                <a16:creationId xmlns:a16="http://schemas.microsoft.com/office/drawing/2014/main" id="{3816997D-4EFC-F085-0715-9933EA35C05E}"/>
+              </a:ext>
+            </a:extLst>
+          </p:cNvPr>
+          <p:cNvSpPr txBox="1"/>
+          <p:nvPr/>
+        </p:nvSpPr>
+        <p:spPr>
+          <a:xfrm>
+            <a:off x="10096500" y="2222500"/>
+            <a:ext cx="6921500" cy="669414"/>
+          </a:xfrm>
+          <a:prstGeom prst="rect">
+            <a:avLst/>
+          </a:prstGeom>
+          <a:noFill/>
+        </p:spPr>
+        <p:txBody>
+          <a:bodyPr vert="horz" rtlCol="0">
+            <a:spAutoFit/>
+          </a:bodyPr>
+          <a:lstStyle/>
+          <a:p>
+            <a:r>
+              <a:rPr lang="en-US" sz="2400" b="1">
+                <a:solidFill>
+                  <a:srgbClr val="06B6D4"/>
+                </a:solidFill>
+                <a:latin typeface="Antonio Bold" panose="020B0604020202020204" charset="0"/>
+              </a:rPr>
+              <a:t>GITHUB REPOSITORY</a:t>
+            </a:r>
+          </a:p>
+          <a:p>
+            <a:r>
+              <a:rPr lang="fr-FR" sz="1350" b="1">
+                <a:solidFill>
+                  <a:srgbClr val="22C55E"/>
+                </a:solidFill>
+                <a:latin typeface="Segoe UI" panose="020B0502040204020203" pitchFamily="34" charset="0"/>
+              </a:rPr>
+              <a:t>Public Monorepo &amp; Implementation Source Code</a:t>
+            </a:r>
+            <a:endParaRPr lang="en-US" sz="1350" b="1">
+              <a:solidFill>
+                <a:srgbClr val="22C55E"/>
+              </a:solidFill>
+              <a:latin typeface="Segoe UI" panose="020B0502040204020203" pitchFamily="34" charset="0"/>
+            </a:endParaRPr>
+          </a:p>
+        </p:txBody>
+      </p:sp>
+      <p:sp>
+        <p:nvSpPr>
+          <p:cNvPr id="9" name="Rectangle: Rounded Corners 8">
+            <a:hlinkClick r:id="rId3"/>
+            <a:extLst>
+              <a:ext uri="{FF2B5EF4-FFF2-40B4-BE49-F238E27FC236}">
+                <a16:creationId xmlns:a16="http://schemas.microsoft.com/office/drawing/2014/main" id="{54BAB015-B0B2-86F6-1E5B-E79911E81D03}"/>
+              </a:ext>
+            </a:extLst>
+          </p:cNvPr>
+          <p:cNvSpPr/>
+          <p:nvPr/>
+        </p:nvSpPr>
+        <p:spPr>
+          <a:xfrm>
+            <a:off x="10096500" y="3175000"/>
+            <a:ext cx="6921500" cy="635000"/>
+          </a:xfrm>
+          <a:prstGeom prst="roundRect">
+            <a:avLst/>
+          </a:prstGeom>
+          <a:solidFill>
+            <a:srgbClr val="0F172A"/>
           </a:solidFill>
           <a:ln w="19050">
             <a:solidFill>
@@ -6445,23 +6699,62 @@
           </a:fontRef>
         </p:style>
         <p:txBody>
-          <a:bodyPr lIns="317500" tIns="317500" rIns="317500" rtlCol="0" anchor="ctr"/>
-          <a:lstStyle/>
-          <a:p>
-            <a:pPr algn="ctr"/>
-            <a:r>
-              <a:rPr lang="en-US" b="1">
+          <a:bodyPr rtlCol="0" anchor="ctr"/>
+          <a:lstStyle/>
+          <a:p>
+            <a:pPr algn="ctr"/>
+            <a:r>
+              <a:rPr lang="en-US" sz="1450" b="1">
+                <a:solidFill>
+                  <a:srgbClr val="FFFFFF"/>
+                </a:solidFill>
+                <a:latin typeface="Segoe UI" panose="020B0502040204020203" pitchFamily="34" charset="0"/>
+              </a:rPr>
+              <a:t>https://github.com/Yokeshwaran03-2005/API-SENTINEL</a:t>
+            </a:r>
+          </a:p>
+        </p:txBody>
+      </p:sp>
+      <p:sp>
+        <p:nvSpPr>
+          <p:cNvPr id="10" name="TextBox 9">
+            <a:extLst>
+              <a:ext uri="{FF2B5EF4-FFF2-40B4-BE49-F238E27FC236}">
+                <a16:creationId xmlns:a16="http://schemas.microsoft.com/office/drawing/2014/main" id="{31A6E7DC-9EC5-1723-8CD6-7CAAB8AF11EC}"/>
+              </a:ext>
+            </a:extLst>
+          </p:cNvPr>
+          <p:cNvSpPr txBox="1"/>
+          <p:nvPr/>
+        </p:nvSpPr>
+        <p:spPr>
+          <a:xfrm>
+            <a:off x="10096500" y="4000500"/>
+            <a:ext cx="6921500" cy="3046988"/>
+          </a:xfrm>
+          <a:prstGeom prst="rect">
+            <a:avLst/>
+          </a:prstGeom>
+          <a:noFill/>
+        </p:spPr>
+        <p:txBody>
+          <a:bodyPr vert="horz" rtlCol="0">
+            <a:spAutoFit/>
+          </a:bodyPr>
+          <a:lstStyle/>
+          <a:p>
+            <a:r>
+              <a:rPr lang="en-US" sz="1500" b="1">
                 <a:solidFill>
                   <a:srgbClr val="06B6D4"/>
                 </a:solidFill>
                 <a:latin typeface="Antonio Bold" panose="020B0604020202020204" charset="0"/>
               </a:rPr>
-              <a:t>TECHNOLOGY FRAMEWORKS &amp; SPECS</a:t>
-            </a:r>
-          </a:p>
-          <a:p>
-            <a:pPr algn="ctr"/>
-            <a:endParaRPr lang="en-US" b="1">
+              <a:t>REPOSITORY CONTENTS:</a:t>
+            </a:r>
+          </a:p>
+          <a:p>
+            <a:endParaRPr lang="en-US" sz="1500" b="1">
               <a:solidFill>
                 <a:srgbClr val="06B6D4"/>
               </a:solidFill>
@@ -6469,7 +6762,6 @@
             </a:endParaRPr>
           </a:p>
           <a:p>
-            <a:pPr algn="ctr"/>
             <a:r>
               <a:rPr lang="en-US" sz="1350">
                 <a:solidFill>
@@ -6477,23 +6769,10 @@
                 </a:solidFill>
                 <a:latin typeface="Segoe UI" panose="020B0502040204020203" pitchFamily="34" charset="0"/>
               </a:rPr>
-              <a:t>- Spring Framework 6 &amp; Spring Boot 3.2</a:t>
-            </a:r>
-          </a:p>
-          <a:p>
-            <a:pPr algn="ctr"/>
-            <a:r>
-              <a:rPr lang="en-US" sz="1350">
-                <a:solidFill>
-                  <a:srgbClr val="E2E8F0"/>
-                </a:solidFill>
-                <a:latin typeface="Segoe UI" panose="020B0502040204020203" pitchFamily="34" charset="0"/>
-              </a:rPr>
-              <a:t>  High-performance enterprise Java reactive and servlet filter architecture; Spring Data JPA and Spring Security.</a:t>
-            </a:r>
-          </a:p>
-          <a:p>
-            <a:pPr algn="ctr"/>
+              <a:t>- Unified Monorepo: Houses complete /backend, /frontend, /database, and container orchestration.</a:t>
+            </a:r>
+          </a:p>
+          <a:p>
             <a:endParaRPr lang="en-US" sz="1350">
               <a:solidFill>
                 <a:srgbClr val="E2E8F0"/>
@@ -6502,7 +6781,6 @@
             </a:endParaRPr>
           </a:p>
           <a:p>
-            <a:pPr algn="ctr"/>
             <a:r>
               <a:rPr lang="en-US" sz="1350">
                 <a:solidFill>
@@ -6510,23 +6788,10 @@
                 </a:solidFill>
                 <a:latin typeface="Segoe UI" panose="020B0502040204020203" pitchFamily="34" charset="0"/>
               </a:rPr>
-              <a:t>- Next.js 14 App Router &amp; React 18</a:t>
-            </a:r>
-          </a:p>
-          <a:p>
-            <a:pPr algn="ctr"/>
-            <a:r>
-              <a:rPr lang="en-US" sz="1350">
-                <a:solidFill>
-                  <a:srgbClr val="E2E8F0"/>
-                </a:solidFill>
-                <a:latin typeface="Segoe UI" panose="020B0502040204020203" pitchFamily="34" charset="0"/>
-              </a:rPr>
-              <a:t>  Modern server-rendered web application framework, edge runtime routing, and Tailwind CSS design system.</a:t>
-            </a:r>
-          </a:p>
-          <a:p>
-            <a:pPr algn="ctr"/>
+              <a:t>- Backend Gateway: Java 17 + Spring Boot 3.2 zero-trust servlet filter chain, heuristics &amp; scoring engine.</a:t>
+            </a:r>
+          </a:p>
+          <a:p>
             <a:endParaRPr lang="en-US" sz="1350">
               <a:solidFill>
                 <a:srgbClr val="E2E8F0"/>
@@ -6535,7 +6800,6 @@
             </a:endParaRPr>
           </a:p>
           <a:p>
-            <a:pPr algn="ctr"/>
             <a:r>
               <a:rPr lang="en-US" sz="1350">
                 <a:solidFill>
@@ -6543,130 +6807,10 @@
                 </a:solidFill>
                 <a:latin typeface="Segoe UI" panose="020B0502040204020203" pitchFamily="34" charset="0"/>
               </a:rPr>
-              <a:t>- PostgreSQL 16 &amp; HikariCP</a:t>
-            </a:r>
-          </a:p>
-          <a:p>
-            <a:pPr algn="ctr"/>
-            <a:r>
-              <a:rPr lang="en-US" sz="1350">
-                <a:solidFill>
-                  <a:srgbClr val="E2E8F0"/>
-                </a:solidFill>
-                <a:latin typeface="Segoe UI" panose="020B0502040204020203" pitchFamily="34" charset="0"/>
-              </a:rPr>
-              <a:t>  ACID-compliant relational persistence, JSONB document querying, and ultra-low latency connection pooling.</a:t>
-            </a:r>
-          </a:p>
-        </p:txBody>
-      </p:sp>
-      <p:sp>
-        <p:nvSpPr>
-          <p:cNvPr id="5" name="Rectangle: Rounded Corners 4">
-            <a:extLst>
-              <a:ext uri="{FF2B5EF4-FFF2-40B4-BE49-F238E27FC236}">
-                <a16:creationId xmlns:a16="http://schemas.microsoft.com/office/drawing/2014/main" id="{0DFA4DC7-F68E-64B4-426D-D5BB6544BE9D}"/>
-              </a:ext>
-            </a:extLst>
-          </p:cNvPr>
-          <p:cNvSpPr/>
-          <p:nvPr/>
-        </p:nvSpPr>
-        <p:spPr>
-          <a:xfrm>
-            <a:off x="12382500" y="1778000"/>
-            <a:ext cx="5016500" cy="7493000"/>
-          </a:xfrm>
-          <a:prstGeom prst="roundRect">
-            <a:avLst/>
-          </a:prstGeom>
-          <a:solidFill>
-            <a:srgbClr val="111827"/>
-          </a:solidFill>
-          <a:ln w="19050">
-            <a:solidFill>
-              <a:srgbClr val="22C55E"/>
-            </a:solidFill>
-          </a:ln>
-        </p:spPr>
-        <p:style>
-          <a:lnRef idx="2">
-            <a:schemeClr val="accent1">
-              <a:shade val="15000"/>
-            </a:schemeClr>
-          </a:lnRef>
-          <a:fillRef idx="1">
-            <a:schemeClr val="accent1"/>
-          </a:fillRef>
-          <a:effectRef idx="0">
-            <a:schemeClr val="accent1"/>
-          </a:effectRef>
-          <a:fontRef idx="minor">
-            <a:schemeClr val="lt1"/>
-          </a:fontRef>
-        </p:style>
-        <p:txBody>
-          <a:bodyPr lIns="317500" tIns="317500" rIns="317500" rtlCol="0" anchor="ctr"/>
-          <a:lstStyle/>
-          <a:p>
-            <a:pPr algn="ctr"/>
-            <a:r>
-              <a:rPr lang="en-US" b="1">
-                <a:solidFill>
-                  <a:srgbClr val="22C55E"/>
-                </a:solidFill>
-                <a:latin typeface="Antonio Bold" panose="020B0604020202020204" charset="0"/>
-              </a:rPr>
-              <a:t>PROJECT LINKS &amp; DEPLOYMENTS</a:t>
-            </a:r>
-          </a:p>
-          <a:p>
-            <a:pPr algn="ctr"/>
-            <a:endParaRPr lang="en-US" b="1">
-              <a:solidFill>
-                <a:srgbClr val="22C55E"/>
-              </a:solidFill>
-              <a:latin typeface="Antonio Bold" panose="020B0604020202020204" charset="0"/>
-            </a:endParaRPr>
-          </a:p>
-          <a:p>
-            <a:pPr algn="ctr"/>
-            <a:r>
-              <a:rPr lang="en-US" sz="1350">
-                <a:solidFill>
-                  <a:srgbClr val="E2E8F0"/>
-                </a:solidFill>
-                <a:latin typeface="Segoe UI" panose="020B0502040204020203" pitchFamily="34" charset="0"/>
-              </a:rPr>
-              <a:t>- GitHub Monorepo:</a:t>
-            </a:r>
-          </a:p>
-          <a:p>
-            <a:pPr algn="ctr"/>
-            <a:r>
-              <a:rPr lang="en-US" sz="1350">
-                <a:solidFill>
-                  <a:srgbClr val="E2E8F0"/>
-                </a:solidFill>
-                <a:latin typeface="Segoe UI" panose="020B0502040204020203" pitchFamily="34" charset="0"/>
-              </a:rPr>
-              <a:t>  https://github.com/Yokeshwaran03-2005/API-SENTINEL</a:t>
-            </a:r>
-          </a:p>
-          <a:p>
-            <a:pPr algn="ctr"/>
-            <a:r>
-              <a:rPr lang="en-US" sz="1350">
-                <a:solidFill>
-                  <a:srgbClr val="E2E8F0"/>
-                </a:solidFill>
-                <a:latin typeface="Segoe UI" panose="020B0502040204020203" pitchFamily="34" charset="0"/>
-              </a:rPr>
-              <a:t>  Complete source code, Docker configs, and setup documentation.</a:t>
-            </a:r>
-          </a:p>
-          <a:p>
-            <a:pPr algn="ctr"/>
+              <a:t>- Frontend Console: Next.js 14 App Router, TypeScript, Tailwind CSS, and Lucide icons.</a:t>
+            </a:r>
+          </a:p>
+          <a:p>
             <a:endParaRPr lang="en-US" sz="1350">
               <a:solidFill>
                 <a:srgbClr val="E2E8F0"/>
@@ -6675,7 +6819,6 @@
             </a:endParaRPr>
           </a:p>
           <a:p>
-            <a:pPr algn="ctr"/>
             <a:r>
               <a:rPr lang="en-US" sz="1350">
                 <a:solidFill>
@@ -6683,35 +6826,10 @@
                 </a:solidFill>
                 <a:latin typeface="Segoe UI" panose="020B0502040204020203" pitchFamily="34" charset="0"/>
               </a:rPr>
-              <a:t>- Live Frontend SOC Dashboard:</a:t>
-            </a:r>
-          </a:p>
-          <a:p>
-            <a:pPr algn="ctr"/>
-            <a:r>
-              <a:rPr lang="en-US" sz="1350">
-                <a:solidFill>
-                  <a:srgbClr val="E2E8F0"/>
-                </a:solidFill>
-                <a:latin typeface="Segoe UI" panose="020B0502040204020203" pitchFamily="34" charset="0"/>
-              </a:rPr>
-              <a:t>  https://apisentinel-psi.vercel.app</a:t>
-            </a:r>
-          </a:p>
-          <a:p>
-            <a:pPr algn="ctr"/>
-            <a:r>
-              <a:rPr lang="en-US" sz="1350">
-                <a:solidFill>
-                  <a:srgbClr val="E2E8F0"/>
-                </a:solidFill>
-                <a:latin typeface="Segoe UI" panose="020B0502040204020203" pitchFamily="34" charset="0"/>
-              </a:rPr>
-              <a:t>  Production deployment on Vercel.</a:t>
-            </a:r>
-          </a:p>
-          <a:p>
-            <a:pPr algn="ctr"/>
+              <a:t>- Comprehensive Documentation: Architecture diagrams, threat model specs, and local Docker Compose setup.</a:t>
+            </a:r>
+          </a:p>
+          <a:p>
             <a:endParaRPr lang="en-US" sz="1350">
               <a:solidFill>
                 <a:srgbClr val="E2E8F0"/>
@@ -6720,7 +6838,6 @@
             </a:endParaRPr>
           </a:p>
           <a:p>
-            <a:pPr algn="ctr"/>
             <a:r>
               <a:rPr lang="en-US" sz="1350">
                 <a:solidFill>
@@ -6728,31 +6845,7 @@
                 </a:solidFill>
                 <a:latin typeface="Segoe UI" panose="020B0502040204020203" pitchFamily="34" charset="0"/>
               </a:rPr>
-              <a:t>- Live Backend API &amp; Health Check:</a:t>
-            </a:r>
-          </a:p>
-          <a:p>
-            <a:pPr algn="ctr"/>
-            <a:r>
-              <a:rPr lang="en-US" sz="1350">
-                <a:solidFill>
-                  <a:srgbClr val="E2E8F0"/>
-                </a:solidFill>
-                <a:latin typeface="Segoe UI" panose="020B0502040204020203" pitchFamily="34" charset="0"/>
-              </a:rPr>
-              <a:t>  https://api-backend-wc8m.onrender.com/api/health</a:t>
-            </a:r>
-          </a:p>
-          <a:p>
-            <a:pPr algn="ctr"/>
-            <a:r>
-              <a:rPr lang="en-US" sz="1350">
-                <a:solidFill>
-                  <a:srgbClr val="E2E8F0"/>
-                </a:solidFill>
-                <a:latin typeface="Segoe UI" panose="020B0502040204020203" pitchFamily="34" charset="0"/>
-              </a:rPr>
-              <a:t>  Production deployment on Render.</a:t>
+              <a:t>- Official Hackathon Submission: Built for INIT'26 by Team Phoenix.</a:t>
             </a:r>
           </a:p>
         </p:txBody>

</xml_diff>

<commit_message>
fix(presentation): replace missing Antonio font with universal Segoe UI to fix text squishing in PowerPoint
</commit_message>
<xml_diff>
--- a/Team_Phoenix_INIT26_Presentation.pptx
+++ b/Team_Phoenix_INIT26_Presentation.pptx
@@ -18,15 +18,11 @@
   <p:notesSz cx="6858000" cy="9144000"/>
   <p:embeddedFontLst>
     <p:embeddedFont>
-      <p:font typeface="Antonio Bold" panose="020B0604020202020204" charset="0"/>
+      <p:font typeface="Segoe UI" panose="020B0502040204020203" pitchFamily="34" charset="0"/>
       <p:regular r:id="rId10"/>
-    </p:embeddedFont>
-    <p:embeddedFont>
-      <p:font typeface="Segoe UI" panose="020B0502040204020203" pitchFamily="34" charset="0"/>
-      <p:regular r:id="rId11"/>
-      <p:bold r:id="rId12"/>
-      <p:italic r:id="rId13"/>
-      <p:boldItalic r:id="rId14"/>
+      <p:bold r:id="rId11"/>
+      <p:italic r:id="rId12"/>
+      <p:boldItalic r:id="rId13"/>
     </p:embeddedFont>
   </p:embeddedFontLst>
   <p:defaultTextStyle>
@@ -3319,7 +3315,7 @@
         <p:spPr>
           <a:xfrm>
             <a:off x="3111988" y="3479703"/>
-            <a:ext cx="12635525" cy="3565719"/>
+            <a:ext cx="12635525" cy="2906308"/>
           </a:xfrm>
           <a:prstGeom prst="rect">
             <a:avLst/>
@@ -3337,11 +3333,11 @@
               </a:lnSpc>
             </a:pPr>
             <a:r>
-              <a:rPr lang="en-US" sz="25015" b="1" spc="-625" dirty="0">
+              <a:rPr lang="en-US" sz="9000" b="1" spc="-625" dirty="0">
                 <a:solidFill>
                   <a:srgbClr val="FFFFFF"/>
                 </a:solidFill>
-                <a:latin typeface="Antonio Bold"/>
+                <a:latin typeface="Segoe UI" panose="020B0502040204020203" pitchFamily="34" charset="0"/>
                 <a:ea typeface="Antonio Bold"/>
                 <a:cs typeface="Antonio Bold"/>
                 <a:sym typeface="Antonio Bold"/>
@@ -3520,7 +3516,7 @@
           <p:cNvPr id="12" name="Rectangle: Rounded Corners 11">
             <a:extLst>
               <a:ext uri="{FF2B5EF4-FFF2-40B4-BE49-F238E27FC236}">
-                <a16:creationId xmlns:a16="http://schemas.microsoft.com/office/drawing/2014/main" id="{E17F563A-4736-37D6-B170-0E0F603C3A35}"/>
+                <a16:creationId xmlns:a16="http://schemas.microsoft.com/office/drawing/2014/main" id="{57DFF858-779B-D8C7-F0FD-563C0D30F86A}"/>
               </a:ext>
             </a:extLst>
           </p:cNvPr>
@@ -3566,11 +3562,11 @@
           <a:p>
             <a:pPr algn="ctr"/>
             <a:r>
-              <a:rPr lang="en-US" b="1">
+              <a:rPr lang="en-US" sz="1600" b="1">
                 <a:solidFill>
                   <a:srgbClr val="FFFFFF"/>
                 </a:solidFill>
-                <a:latin typeface="Antonio Bold" panose="020B0604020202020204" charset="0"/>
+                <a:latin typeface="Segoe UI" panose="020B0502040204020203" pitchFamily="34" charset="0"/>
               </a:rPr>
               <a:t>TEAM: PHOENIX   |   TRACK: CYBERSECURITY   |   PROJECT: API SENTINEL</a:t>
             </a:r>
@@ -3611,7 +3607,7 @@
         <p:spPr>
           <a:xfrm>
             <a:off x="1469107" y="392252"/>
-            <a:ext cx="13898868" cy="1203325"/>
+            <a:ext cx="13898868" cy="1033873"/>
           </a:xfrm>
           <a:prstGeom prst="rect">
             <a:avLst/>
@@ -3629,11 +3625,11 @@
               </a:lnSpc>
             </a:pPr>
             <a:r>
-              <a:rPr lang="en-US" sz="8499" b="1" spc="-212">
+              <a:rPr lang="en-US" sz="4800" b="1" spc="-212">
                 <a:solidFill>
                   <a:srgbClr val="FFFFFF"/>
                 </a:solidFill>
-                <a:latin typeface="Antonio Bold"/>
+                <a:latin typeface="Segoe UI" panose="020B0502040204020203" pitchFamily="34" charset="0"/>
                 <a:ea typeface="Antonio Bold"/>
                 <a:cs typeface="Antonio Bold"/>
                 <a:sym typeface="Antonio Bold"/>
@@ -3648,7 +3644,7 @@
           <p:cNvPr id="2" name="Rectangle: Rounded Corners 1">
             <a:extLst>
               <a:ext uri="{FF2B5EF4-FFF2-40B4-BE49-F238E27FC236}">
-                <a16:creationId xmlns:a16="http://schemas.microsoft.com/office/drawing/2014/main" id="{D6A930CA-6C98-1545-CDE8-BE9238C8F512}"/>
+                <a16:creationId xmlns:a16="http://schemas.microsoft.com/office/drawing/2014/main" id="{2365754B-B286-223C-29B7-8A5A2115457B}"/>
               </a:ext>
             </a:extLst>
           </p:cNvPr>
@@ -3694,11 +3690,11 @@
           <a:p>
             <a:pPr algn="ctr"/>
             <a:r>
-              <a:rPr lang="en-US" sz="2400" b="1">
+              <a:rPr lang="en-US" sz="2000" b="1">
                 <a:solidFill>
                   <a:srgbClr val="22C55E"/>
                 </a:solidFill>
-                <a:latin typeface="Antonio Bold" panose="020B0604020202020204" charset="0"/>
+                <a:latin typeface="Segoe UI" panose="020B0502040204020203" pitchFamily="34" charset="0"/>
               </a:rPr>
               <a:t>TRACK : </a:t>
             </a:r>
@@ -3706,7 +3702,7 @@
           <a:p>
             <a:pPr algn="ctr"/>
             <a:r>
-              <a:rPr lang="en-US" sz="2000" b="1">
+              <a:rPr lang="en-US" b="1">
                 <a:solidFill>
                   <a:srgbClr val="FFFFFF"/>
                 </a:solidFill>
@@ -3717,7 +3713,7 @@
           </a:p>
           <a:p>
             <a:pPr algn="ctr"/>
-            <a:endParaRPr lang="en-US" sz="2000" b="1">
+            <a:endParaRPr lang="en-US" b="1">
               <a:solidFill>
                 <a:srgbClr val="FFFFFF"/>
               </a:solidFill>
@@ -3727,11 +3723,11 @@
           <a:p>
             <a:pPr algn="ctr"/>
             <a:r>
-              <a:rPr lang="en-US" sz="2400" b="1">
+              <a:rPr lang="en-US" sz="2000" b="1">
                 <a:solidFill>
                   <a:srgbClr val="22C55E"/>
                 </a:solidFill>
-                <a:latin typeface="Antonio Bold" panose="020B0604020202020204" charset="0"/>
+                <a:latin typeface="Segoe UI" panose="020B0502040204020203" pitchFamily="34" charset="0"/>
               </a:rPr>
               <a:t>PROBLEM STATEMENT : </a:t>
             </a:r>
@@ -3739,7 +3735,7 @@
           <a:p>
             <a:pPr algn="ctr"/>
             <a:r>
-              <a:rPr lang="en-US" sz="1600">
+              <a:rPr lang="en-US" sz="1550">
                 <a:solidFill>
                   <a:srgbClr val="E2E8F0"/>
                 </a:solidFill>
@@ -3750,7 +3746,7 @@
           </a:p>
           <a:p>
             <a:pPr algn="ctr"/>
-            <a:endParaRPr lang="en-US" sz="1600">
+            <a:endParaRPr lang="en-US" sz="1550">
               <a:solidFill>
                 <a:srgbClr val="E2E8F0"/>
               </a:solidFill>
@@ -3760,11 +3756,11 @@
           <a:p>
             <a:pPr algn="ctr"/>
             <a:r>
-              <a:rPr lang="en-US" sz="2400" b="1">
+              <a:rPr lang="en-US" sz="2000" b="1">
                 <a:solidFill>
                   <a:srgbClr val="22C55E"/>
                 </a:solidFill>
-                <a:latin typeface="Antonio Bold" panose="020B0604020202020204" charset="0"/>
+                <a:latin typeface="Segoe UI" panose="020B0502040204020203" pitchFamily="34" charset="0"/>
               </a:rPr>
               <a:t>TEAM NAME : </a:t>
             </a:r>
@@ -3772,7 +3768,7 @@
           <a:p>
             <a:pPr algn="ctr"/>
             <a:r>
-              <a:rPr lang="en-US" sz="2000" b="1">
+              <a:rPr lang="en-US" b="1">
                 <a:solidFill>
                   <a:srgbClr val="FFFFFF"/>
                 </a:solidFill>
@@ -3783,7 +3779,7 @@
           </a:p>
           <a:p>
             <a:pPr algn="ctr"/>
-            <a:endParaRPr lang="en-US" sz="2000" b="1">
+            <a:endParaRPr lang="en-US" b="1">
               <a:solidFill>
                 <a:srgbClr val="FFFFFF"/>
               </a:solidFill>
@@ -3793,11 +3789,11 @@
           <a:p>
             <a:pPr algn="ctr"/>
             <a:r>
-              <a:rPr lang="en-US" sz="2400" b="1">
+              <a:rPr lang="en-US" sz="2000" b="1">
                 <a:solidFill>
                   <a:srgbClr val="22C55E"/>
                 </a:solidFill>
-                <a:latin typeface="Antonio Bold" panose="020B0604020202020204" charset="0"/>
+                <a:latin typeface="Segoe UI" panose="020B0502040204020203" pitchFamily="34" charset="0"/>
               </a:rPr>
               <a:t>IDEA TITLE : </a:t>
             </a:r>
@@ -3805,7 +3801,7 @@
           <a:p>
             <a:pPr algn="ctr"/>
             <a:r>
-              <a:rPr lang="en-US" sz="2000" b="1">
+              <a:rPr lang="en-US" sz="1900" b="1">
                 <a:solidFill>
                   <a:srgbClr val="06B6D4"/>
                 </a:solidFill>
@@ -3850,7 +3846,7 @@
         <p:spPr>
           <a:xfrm>
             <a:off x="1469107" y="392252"/>
-            <a:ext cx="13898868" cy="1203325"/>
+            <a:ext cx="13898868" cy="1033873"/>
           </a:xfrm>
           <a:prstGeom prst="rect">
             <a:avLst/>
@@ -3868,11 +3864,11 @@
               </a:lnSpc>
             </a:pPr>
             <a:r>
-              <a:rPr lang="en-US" sz="8499" b="1" spc="-212">
+              <a:rPr lang="en-US" sz="4800" b="1" spc="-212">
                 <a:solidFill>
                   <a:srgbClr val="FFFFFF"/>
                 </a:solidFill>
-                <a:latin typeface="Antonio Bold"/>
+                <a:latin typeface="Segoe UI" panose="020B0502040204020203" pitchFamily="34" charset="0"/>
                 <a:ea typeface="Antonio Bold"/>
                 <a:cs typeface="Antonio Bold"/>
                 <a:sym typeface="Antonio Bold"/>
@@ -3887,7 +3883,7 @@
           <p:cNvPr id="2" name="Rectangle: Rounded Corners 1">
             <a:extLst>
               <a:ext uri="{FF2B5EF4-FFF2-40B4-BE49-F238E27FC236}">
-                <a16:creationId xmlns:a16="http://schemas.microsoft.com/office/drawing/2014/main" id="{A192A530-982A-463B-6B63-143BAFEE717E}"/>
+                <a16:creationId xmlns:a16="http://schemas.microsoft.com/office/drawing/2014/main" id="{F2F3D447-E07C-3C1B-B713-045C138E3B9B}"/>
               </a:ext>
             </a:extLst>
           </p:cNvPr>
@@ -3933,28 +3929,28 @@
           <a:p>
             <a:pPr algn="ctr"/>
             <a:r>
-              <a:rPr lang="en-US" b="1">
+              <a:rPr lang="en-US" sz="1450" b="1">
                 <a:solidFill>
                   <a:srgbClr val="06B6D4"/>
                 </a:solidFill>
-                <a:latin typeface="Antonio Bold" panose="020B0604020202020204" charset="0"/>
+                <a:latin typeface="Segoe UI" panose="020B0502040204020203" pitchFamily="34" charset="0"/>
               </a:rPr>
               <a:t>01. INGESTION &amp; INTERCEPTION</a:t>
             </a:r>
           </a:p>
           <a:p>
             <a:pPr algn="ctr"/>
-            <a:endParaRPr lang="en-US" b="1">
+            <a:endParaRPr lang="en-US" sz="1450" b="1">
               <a:solidFill>
                 <a:srgbClr val="06B6D4"/>
               </a:solidFill>
-              <a:latin typeface="Antonio Bold" panose="020B0604020202020204" charset="0"/>
+              <a:latin typeface="Segoe UI" panose="020B0502040204020203" pitchFamily="34" charset="0"/>
             </a:endParaRPr>
           </a:p>
           <a:p>
             <a:pPr algn="ctr"/>
             <a:r>
-              <a:rPr lang="en-US" b="1">
+              <a:rPr lang="en-US" sz="1700" b="1">
                 <a:solidFill>
                   <a:srgbClr val="FFFFFF"/>
                 </a:solidFill>
@@ -3965,7 +3961,7 @@
           </a:p>
           <a:p>
             <a:pPr algn="ctr"/>
-            <a:endParaRPr lang="en-US" b="1">
+            <a:endParaRPr lang="en-US" sz="1700" b="1">
               <a:solidFill>
                 <a:srgbClr val="FFFFFF"/>
               </a:solidFill>
@@ -3975,7 +3971,7 @@
           <a:p>
             <a:pPr algn="ctr"/>
             <a:r>
-              <a:rPr lang="en-US" sz="1400">
+              <a:rPr lang="en-US" sz="1300">
                 <a:solidFill>
                   <a:srgbClr val="E2E8F0"/>
                 </a:solidFill>
@@ -3986,7 +3982,7 @@
           </a:p>
           <a:p>
             <a:pPr algn="ctr"/>
-            <a:endParaRPr lang="en-US" sz="1400">
+            <a:endParaRPr lang="en-US" sz="1300">
               <a:solidFill>
                 <a:srgbClr val="E2E8F0"/>
               </a:solidFill>
@@ -3996,7 +3992,7 @@
           <a:p>
             <a:pPr algn="ctr"/>
             <a:r>
-              <a:rPr lang="en-US" sz="1400">
+              <a:rPr lang="en-US" sz="1300">
                 <a:solidFill>
                   <a:srgbClr val="E2E8F0"/>
                 </a:solidFill>
@@ -4007,7 +4003,7 @@
           </a:p>
           <a:p>
             <a:pPr algn="ctr"/>
-            <a:endParaRPr lang="en-US" sz="1400">
+            <a:endParaRPr lang="en-US" sz="1300">
               <a:solidFill>
                 <a:srgbClr val="E2E8F0"/>
               </a:solidFill>
@@ -4017,7 +4013,7 @@
           <a:p>
             <a:pPr algn="ctr"/>
             <a:r>
-              <a:rPr lang="en-US" sz="1400">
+              <a:rPr lang="en-US" sz="1300">
                 <a:solidFill>
                   <a:srgbClr val="E2E8F0"/>
                 </a:solidFill>
@@ -4033,7 +4029,7 @@
           <p:cNvPr id="3" name="Rectangle: Rounded Corners 2">
             <a:extLst>
               <a:ext uri="{FF2B5EF4-FFF2-40B4-BE49-F238E27FC236}">
-                <a16:creationId xmlns:a16="http://schemas.microsoft.com/office/drawing/2014/main" id="{D0CBF521-24CA-0244-6A52-FB2C4D5D1560}"/>
+                <a16:creationId xmlns:a16="http://schemas.microsoft.com/office/drawing/2014/main" id="{4A235910-CE57-0430-87CF-512253195B02}"/>
               </a:ext>
             </a:extLst>
           </p:cNvPr>
@@ -4079,28 +4075,28 @@
           <a:p>
             <a:pPr algn="ctr"/>
             <a:r>
-              <a:rPr lang="en-US" b="1">
+              <a:rPr lang="en-US" sz="1450" b="1">
                 <a:solidFill>
                   <a:srgbClr val="22C55E"/>
                 </a:solidFill>
-                <a:latin typeface="Antonio Bold" panose="020B0604020202020204" charset="0"/>
+                <a:latin typeface="Segoe UI" panose="020B0502040204020203" pitchFamily="34" charset="0"/>
               </a:rPr>
               <a:t>02. THREAT DETECTION &amp; SCORING</a:t>
             </a:r>
           </a:p>
           <a:p>
             <a:pPr algn="ctr"/>
-            <a:endParaRPr lang="en-US" b="1">
+            <a:endParaRPr lang="en-US" sz="1450" b="1">
               <a:solidFill>
                 <a:srgbClr val="22C55E"/>
               </a:solidFill>
-              <a:latin typeface="Antonio Bold" panose="020B0604020202020204" charset="0"/>
+              <a:latin typeface="Segoe UI" panose="020B0502040204020203" pitchFamily="34" charset="0"/>
             </a:endParaRPr>
           </a:p>
           <a:p>
             <a:pPr algn="ctr"/>
             <a:r>
-              <a:rPr lang="en-US" b="1">
+              <a:rPr lang="en-US" sz="1700" b="1">
                 <a:solidFill>
                   <a:srgbClr val="FFFFFF"/>
                 </a:solidFill>
@@ -4111,7 +4107,7 @@
           </a:p>
           <a:p>
             <a:pPr algn="ctr"/>
-            <a:endParaRPr lang="en-US" b="1">
+            <a:endParaRPr lang="en-US" sz="1700" b="1">
               <a:solidFill>
                 <a:srgbClr val="FFFFFF"/>
               </a:solidFill>
@@ -4121,7 +4117,7 @@
           <a:p>
             <a:pPr algn="ctr"/>
             <a:r>
-              <a:rPr lang="en-US" sz="1400">
+              <a:rPr lang="en-US" sz="1300">
                 <a:solidFill>
                   <a:srgbClr val="E2E8F0"/>
                 </a:solidFill>
@@ -4132,7 +4128,7 @@
           </a:p>
           <a:p>
             <a:pPr algn="ctr"/>
-            <a:endParaRPr lang="en-US" sz="1400">
+            <a:endParaRPr lang="en-US" sz="1300">
               <a:solidFill>
                 <a:srgbClr val="E2E8F0"/>
               </a:solidFill>
@@ -4142,7 +4138,7 @@
           <a:p>
             <a:pPr algn="ctr"/>
             <a:r>
-              <a:rPr lang="en-US" sz="1400">
+              <a:rPr lang="en-US" sz="1300">
                 <a:solidFill>
                   <a:srgbClr val="E2E8F0"/>
                 </a:solidFill>
@@ -4153,7 +4149,7 @@
           </a:p>
           <a:p>
             <a:pPr algn="ctr"/>
-            <a:endParaRPr lang="en-US" sz="1400">
+            <a:endParaRPr lang="en-US" sz="1300">
               <a:solidFill>
                 <a:srgbClr val="E2E8F0"/>
               </a:solidFill>
@@ -4163,7 +4159,7 @@
           <a:p>
             <a:pPr algn="ctr"/>
             <a:r>
-              <a:rPr lang="en-US" sz="1400">
+              <a:rPr lang="en-US" sz="1300">
                 <a:solidFill>
                   <a:srgbClr val="E2E8F0"/>
                 </a:solidFill>
@@ -4179,7 +4175,7 @@
           <p:cNvPr id="5" name="Rectangle: Rounded Corners 4">
             <a:extLst>
               <a:ext uri="{FF2B5EF4-FFF2-40B4-BE49-F238E27FC236}">
-                <a16:creationId xmlns:a16="http://schemas.microsoft.com/office/drawing/2014/main" id="{C8DEBF11-021F-D05E-37A1-D3942213B898}"/>
+                <a16:creationId xmlns:a16="http://schemas.microsoft.com/office/drawing/2014/main" id="{6345DD2E-0ABE-9C63-D490-3B344976BF73}"/>
               </a:ext>
             </a:extLst>
           </p:cNvPr>
@@ -4225,28 +4221,28 @@
           <a:p>
             <a:pPr algn="ctr"/>
             <a:r>
-              <a:rPr lang="en-US" b="1">
+              <a:rPr lang="en-US" sz="1450" b="1">
                 <a:solidFill>
                   <a:srgbClr val="06B6D4"/>
                 </a:solidFill>
-                <a:latin typeface="Antonio Bold" panose="020B0604020202020204" charset="0"/>
+                <a:latin typeface="Segoe UI" panose="020B0502040204020203" pitchFamily="34" charset="0"/>
               </a:rPr>
               <a:t>03. MITIGATION &amp; OBSERVABILITY</a:t>
             </a:r>
           </a:p>
           <a:p>
             <a:pPr algn="ctr"/>
-            <a:endParaRPr lang="en-US" b="1">
+            <a:endParaRPr lang="en-US" sz="1450" b="1">
               <a:solidFill>
                 <a:srgbClr val="06B6D4"/>
               </a:solidFill>
-              <a:latin typeface="Antonio Bold" panose="020B0604020202020204" charset="0"/>
+              <a:latin typeface="Segoe UI" panose="020B0502040204020203" pitchFamily="34" charset="0"/>
             </a:endParaRPr>
           </a:p>
           <a:p>
             <a:pPr algn="ctr"/>
             <a:r>
-              <a:rPr lang="en-US" b="1">
+              <a:rPr lang="en-US" sz="1700" b="1">
                 <a:solidFill>
                   <a:srgbClr val="FFFFFF"/>
                 </a:solidFill>
@@ -4257,7 +4253,7 @@
           </a:p>
           <a:p>
             <a:pPr algn="ctr"/>
-            <a:endParaRPr lang="en-US" b="1">
+            <a:endParaRPr lang="en-US" sz="1700" b="1">
               <a:solidFill>
                 <a:srgbClr val="FFFFFF"/>
               </a:solidFill>
@@ -4267,7 +4263,7 @@
           <a:p>
             <a:pPr algn="ctr"/>
             <a:r>
-              <a:rPr lang="en-US" sz="1400">
+              <a:rPr lang="en-US" sz="1300">
                 <a:solidFill>
                   <a:srgbClr val="E2E8F0"/>
                 </a:solidFill>
@@ -4278,7 +4274,7 @@
           </a:p>
           <a:p>
             <a:pPr algn="ctr"/>
-            <a:endParaRPr lang="en-US" sz="1400">
+            <a:endParaRPr lang="en-US" sz="1300">
               <a:solidFill>
                 <a:srgbClr val="E2E8F0"/>
               </a:solidFill>
@@ -4288,7 +4284,7 @@
           <a:p>
             <a:pPr algn="ctr"/>
             <a:r>
-              <a:rPr lang="en-US" sz="1400">
+              <a:rPr lang="en-US" sz="1300">
                 <a:solidFill>
                   <a:srgbClr val="E2E8F0"/>
                 </a:solidFill>
@@ -4299,7 +4295,7 @@
           </a:p>
           <a:p>
             <a:pPr algn="ctr"/>
-            <a:endParaRPr lang="en-US" sz="1400">
+            <a:endParaRPr lang="en-US" sz="1300">
               <a:solidFill>
                 <a:srgbClr val="E2E8F0"/>
               </a:solidFill>
@@ -4309,7 +4305,7 @@
           <a:p>
             <a:pPr algn="ctr"/>
             <a:r>
-              <a:rPr lang="en-US" sz="1400">
+              <a:rPr lang="en-US" sz="1300">
                 <a:solidFill>
                   <a:srgbClr val="E2E8F0"/>
                 </a:solidFill>
@@ -4354,7 +4350,7 @@
         <p:spPr>
           <a:xfrm>
             <a:off x="1469107" y="392252"/>
-            <a:ext cx="13898868" cy="1203325"/>
+            <a:ext cx="13898868" cy="1033873"/>
           </a:xfrm>
           <a:prstGeom prst="rect">
             <a:avLst/>
@@ -4372,11 +4368,11 @@
               </a:lnSpc>
             </a:pPr>
             <a:r>
-              <a:rPr lang="en-US" sz="8499" b="1" spc="-212">
+              <a:rPr lang="en-US" sz="4800" b="1" spc="-212">
                 <a:solidFill>
                   <a:srgbClr val="FFFFFF"/>
                 </a:solidFill>
-                <a:latin typeface="Antonio Bold"/>
+                <a:latin typeface="Segoe UI" panose="020B0502040204020203" pitchFamily="34" charset="0"/>
                 <a:ea typeface="Antonio Bold"/>
                 <a:cs typeface="Antonio Bold"/>
                 <a:sym typeface="Antonio Bold"/>
@@ -4391,7 +4387,7 @@
           <p:cNvPr id="2" name="Rectangle: Rounded Corners 1">
             <a:extLst>
               <a:ext uri="{FF2B5EF4-FFF2-40B4-BE49-F238E27FC236}">
-                <a16:creationId xmlns:a16="http://schemas.microsoft.com/office/drawing/2014/main" id="{8B7E79E6-31D9-5CD5-5A71-05D5D80FFFE5}"/>
+                <a16:creationId xmlns:a16="http://schemas.microsoft.com/office/drawing/2014/main" id="{134458C7-3310-1688-2116-1F8A8F1EBD66}"/>
               </a:ext>
             </a:extLst>
           </p:cNvPr>
@@ -4437,11 +4433,11 @@
           <a:p>
             <a:pPr algn="ctr"/>
             <a:r>
-              <a:rPr lang="en-US" b="1">
+              <a:rPr lang="en-US" sz="1550" b="1">
                 <a:solidFill>
                   <a:srgbClr val="06B6D4"/>
                 </a:solidFill>
-                <a:latin typeface="Antonio Bold" panose="020B0604020202020204" charset="0"/>
+                <a:latin typeface="Segoe UI" panose="020B0502040204020203" pitchFamily="34" charset="0"/>
               </a:rPr>
               <a:t>FRONTEND : SECURITY OPERATIONS CENTER (SOC)</a:t>
             </a:r>
@@ -4449,7 +4445,7 @@
           <a:p>
             <a:pPr algn="ctr"/>
             <a:r>
-              <a:rPr lang="en-US" sz="1350">
+              <a:rPr lang="en-US" sz="1250">
                 <a:solidFill>
                   <a:srgbClr val="E2E8F0"/>
                 </a:solidFill>
@@ -4461,7 +4457,7 @@
           <a:p>
             <a:pPr algn="ctr"/>
             <a:r>
-              <a:rPr lang="en-US" sz="1350">
+              <a:rPr lang="en-US" sz="1250">
                 <a:solidFill>
                   <a:srgbClr val="E2E8F0"/>
                 </a:solidFill>
@@ -4473,7 +4469,7 @@
           <a:p>
             <a:pPr algn="ctr"/>
             <a:r>
-              <a:rPr lang="en-US" sz="1350">
+              <a:rPr lang="en-US" sz="1250">
                 <a:solidFill>
                   <a:srgbClr val="E2E8F0"/>
                 </a:solidFill>
@@ -4485,7 +4481,7 @@
           <a:p>
             <a:pPr algn="ctr"/>
             <a:r>
-              <a:rPr lang="en-US" sz="1350">
+              <a:rPr lang="en-US" sz="1250">
                 <a:solidFill>
                   <a:srgbClr val="E2E8F0"/>
                 </a:solidFill>
@@ -4501,7 +4497,7 @@
           <p:cNvPr id="3" name="Rectangle: Rounded Corners 2">
             <a:extLst>
               <a:ext uri="{FF2B5EF4-FFF2-40B4-BE49-F238E27FC236}">
-                <a16:creationId xmlns:a16="http://schemas.microsoft.com/office/drawing/2014/main" id="{BF9E5E57-9C35-9ABC-8FC7-FF44536E9A84}"/>
+                <a16:creationId xmlns:a16="http://schemas.microsoft.com/office/drawing/2014/main" id="{D44659A1-33F3-BC08-226A-C56CCCEC586D}"/>
               </a:ext>
             </a:extLst>
           </p:cNvPr>
@@ -4547,11 +4543,11 @@
           <a:p>
             <a:pPr algn="ctr"/>
             <a:r>
-              <a:rPr lang="en-US" b="1">
+              <a:rPr lang="en-US" sz="1550" b="1">
                 <a:solidFill>
                   <a:srgbClr val="22C55E"/>
                 </a:solidFill>
-                <a:latin typeface="Antonio Bold" panose="020B0604020202020204" charset="0"/>
+                <a:latin typeface="Segoe UI" panose="020B0502040204020203" pitchFamily="34" charset="0"/>
               </a:rPr>
               <a:t>BACKEND : ZERO-TRUST API SECURITY GATEWAY</a:t>
             </a:r>
@@ -4559,7 +4555,7 @@
           <a:p>
             <a:pPr algn="ctr"/>
             <a:r>
-              <a:rPr lang="en-US" sz="1350">
+              <a:rPr lang="en-US" sz="1250">
                 <a:solidFill>
                   <a:srgbClr val="E2E8F0"/>
                 </a:solidFill>
@@ -4571,7 +4567,7 @@
           <a:p>
             <a:pPr algn="ctr"/>
             <a:r>
-              <a:rPr lang="en-US" sz="1350">
+              <a:rPr lang="en-US" sz="1250">
                 <a:solidFill>
                   <a:srgbClr val="E2E8F0"/>
                 </a:solidFill>
@@ -4583,7 +4579,7 @@
           <a:p>
             <a:pPr algn="ctr"/>
             <a:r>
-              <a:rPr lang="en-US" sz="1350">
+              <a:rPr lang="en-US" sz="1250">
                 <a:solidFill>
                   <a:srgbClr val="E2E8F0"/>
                 </a:solidFill>
@@ -4595,7 +4591,7 @@
           <a:p>
             <a:pPr algn="ctr"/>
             <a:r>
-              <a:rPr lang="en-US" sz="1350">
+              <a:rPr lang="en-US" sz="1250">
                 <a:solidFill>
                   <a:srgbClr val="E2E8F0"/>
                 </a:solidFill>
@@ -4611,7 +4607,7 @@
           <p:cNvPr id="5" name="Rectangle: Rounded Corners 4">
             <a:extLst>
               <a:ext uri="{FF2B5EF4-FFF2-40B4-BE49-F238E27FC236}">
-                <a16:creationId xmlns:a16="http://schemas.microsoft.com/office/drawing/2014/main" id="{709464AC-E2E7-98F9-193C-FD3615161B4C}"/>
+                <a16:creationId xmlns:a16="http://schemas.microsoft.com/office/drawing/2014/main" id="{DDDB0E1D-5CB1-2CC6-124D-18CD58BB98C1}"/>
               </a:ext>
             </a:extLst>
           </p:cNvPr>
@@ -4620,7 +4616,7 @@
         </p:nvSpPr>
         <p:spPr>
           <a:xfrm>
-            <a:off x="1460500" y="5651500"/>
+            <a:off x="1460500" y="5715000"/>
             <a:ext cx="7747000" cy="3556000"/>
           </a:xfrm>
           <a:prstGeom prst="roundRect">
@@ -4657,11 +4653,11 @@
           <a:p>
             <a:pPr algn="ctr"/>
             <a:r>
-              <a:rPr lang="en-US" b="1">
+              <a:rPr lang="en-US" sz="1550" b="1">
                 <a:solidFill>
                   <a:srgbClr val="22C55E"/>
                 </a:solidFill>
-                <a:latin typeface="Antonio Bold" panose="020B0604020202020204" charset="0"/>
+                <a:latin typeface="Segoe UI" panose="020B0502040204020203" pitchFamily="34" charset="0"/>
               </a:rPr>
               <a:t>CORE DETECTION &amp; SCORING PIPELINE</a:t>
             </a:r>
@@ -4669,7 +4665,7 @@
           <a:p>
             <a:pPr algn="ctr"/>
             <a:r>
-              <a:rPr lang="en-US" sz="1350">
+              <a:rPr lang="en-US" sz="1250">
                 <a:solidFill>
                   <a:srgbClr val="E2E8F0"/>
                 </a:solidFill>
@@ -4681,7 +4677,7 @@
           <a:p>
             <a:pPr algn="ctr"/>
             <a:r>
-              <a:rPr lang="en-US" sz="1350">
+              <a:rPr lang="en-US" sz="1250">
                 <a:solidFill>
                   <a:srgbClr val="E2E8F0"/>
                 </a:solidFill>
@@ -4693,7 +4689,7 @@
           <a:p>
             <a:pPr algn="ctr"/>
             <a:r>
-              <a:rPr lang="en-US" sz="1350">
+              <a:rPr lang="en-US" sz="1250">
                 <a:solidFill>
                   <a:srgbClr val="E2E8F0"/>
                 </a:solidFill>
@@ -4705,7 +4701,7 @@
           <a:p>
             <a:pPr algn="ctr"/>
             <a:r>
-              <a:rPr lang="en-US" sz="1350">
+              <a:rPr lang="en-US" sz="1250">
                 <a:solidFill>
                   <a:srgbClr val="E2E8F0"/>
                 </a:solidFill>
@@ -4721,7 +4717,7 @@
           <p:cNvPr id="6" name="Rectangle: Rounded Corners 5">
             <a:extLst>
               <a:ext uri="{FF2B5EF4-FFF2-40B4-BE49-F238E27FC236}">
-                <a16:creationId xmlns:a16="http://schemas.microsoft.com/office/drawing/2014/main" id="{75527663-180A-0B3B-E34D-51BA72A80378}"/>
+                <a16:creationId xmlns:a16="http://schemas.microsoft.com/office/drawing/2014/main" id="{D1D20D44-DA4B-8A81-1B82-C2D84591DCB3}"/>
               </a:ext>
             </a:extLst>
           </p:cNvPr>
@@ -4730,7 +4726,7 @@
         </p:nvSpPr>
         <p:spPr>
           <a:xfrm>
-            <a:off x="9652000" y="5651500"/>
+            <a:off x="9652000" y="5715000"/>
             <a:ext cx="7747000" cy="3556000"/>
           </a:xfrm>
           <a:prstGeom prst="roundRect">
@@ -4767,11 +4763,11 @@
           <a:p>
             <a:pPr algn="ctr"/>
             <a:r>
-              <a:rPr lang="en-US" b="1">
+              <a:rPr lang="en-US" sz="1550" b="1">
                 <a:solidFill>
                   <a:srgbClr val="06B6D4"/>
                 </a:solidFill>
-                <a:latin typeface="Antonio Bold" panose="020B0604020202020204" charset="0"/>
+                <a:latin typeface="Segoe UI" panose="020B0502040204020203" pitchFamily="34" charset="0"/>
               </a:rPr>
               <a:t>PERSISTENCE &amp; MONOREPO CLOUD ARCHITECTURE</a:t>
             </a:r>
@@ -4779,7 +4775,7 @@
           <a:p>
             <a:pPr algn="ctr"/>
             <a:r>
-              <a:rPr lang="en-US" sz="1350">
+              <a:rPr lang="en-US" sz="1250">
                 <a:solidFill>
                   <a:srgbClr val="E2E8F0"/>
                 </a:solidFill>
@@ -4791,7 +4787,7 @@
           <a:p>
             <a:pPr algn="ctr"/>
             <a:r>
-              <a:rPr lang="en-US" sz="1350">
+              <a:rPr lang="en-US" sz="1250">
                 <a:solidFill>
                   <a:srgbClr val="E2E8F0"/>
                 </a:solidFill>
@@ -4803,7 +4799,7 @@
           <a:p>
             <a:pPr algn="ctr"/>
             <a:r>
-              <a:rPr lang="en-US" sz="1350">
+              <a:rPr lang="en-US" sz="1250">
                 <a:solidFill>
                   <a:srgbClr val="E2E8F0"/>
                 </a:solidFill>
@@ -4815,7 +4811,7 @@
           <a:p>
             <a:pPr algn="ctr"/>
             <a:r>
-              <a:rPr lang="en-US" sz="1350">
+              <a:rPr lang="en-US" sz="1250">
                 <a:solidFill>
                   <a:srgbClr val="E2E8F0"/>
                 </a:solidFill>
@@ -4860,7 +4856,7 @@
         <p:spPr>
           <a:xfrm>
             <a:off x="1469107" y="392252"/>
-            <a:ext cx="16136995" cy="1203325"/>
+            <a:ext cx="16136995" cy="1033873"/>
           </a:xfrm>
           <a:prstGeom prst="rect">
             <a:avLst/>
@@ -4878,11 +4874,11 @@
               </a:lnSpc>
             </a:pPr>
             <a:r>
-              <a:rPr lang="en-US" sz="8499" b="1" spc="-212">
+              <a:rPr lang="en-US" sz="4800" b="1" spc="-212">
                 <a:solidFill>
                   <a:srgbClr val="FFFFFF"/>
                 </a:solidFill>
-                <a:latin typeface="Antonio Bold"/>
+                <a:latin typeface="Segoe UI" panose="020B0502040204020203" pitchFamily="34" charset="0"/>
                 <a:ea typeface="Antonio Bold"/>
                 <a:cs typeface="Antonio Bold"/>
                 <a:sym typeface="Antonio Bold"/>
@@ -4897,7 +4893,7 @@
           <p:cNvPr id="2" name="Rectangle: Rounded Corners 1">
             <a:extLst>
               <a:ext uri="{FF2B5EF4-FFF2-40B4-BE49-F238E27FC236}">
-                <a16:creationId xmlns:a16="http://schemas.microsoft.com/office/drawing/2014/main" id="{3D3AB14B-2FE2-E842-EC38-E3A04232CBEF}"/>
+                <a16:creationId xmlns:a16="http://schemas.microsoft.com/office/drawing/2014/main" id="{38EA8763-4EE7-EE81-D711-2F9FB56CD400}"/>
               </a:ext>
             </a:extLst>
           </p:cNvPr>
@@ -4907,7 +4903,7 @@
         <p:spPr>
           <a:xfrm>
             <a:off x="1460500" y="1778000"/>
-            <a:ext cx="5016500" cy="3492500"/>
+            <a:ext cx="5016500" cy="3556000"/>
           </a:xfrm>
           <a:prstGeom prst="roundRect">
             <a:avLst/>
@@ -4938,33 +4934,33 @@
           </a:fontRef>
         </p:style>
         <p:txBody>
-          <a:bodyPr lIns="317500" tIns="254000" rIns="317500" rtlCol="0" anchor="ctr"/>
-          <a:lstStyle/>
-          <a:p>
-            <a:pPr algn="ctr"/>
-            <a:r>
-              <a:rPr lang="en-US" sz="1700" b="1">
+          <a:bodyPr lIns="317500" tIns="317500" rIns="317500" rtlCol="0" anchor="ctr"/>
+          <a:lstStyle/>
+          <a:p>
+            <a:pPr algn="ctr"/>
+            <a:r>
+              <a:rPr lang="en-US" sz="1450" b="1">
                 <a:solidFill>
                   <a:srgbClr val="06B6D4"/>
                 </a:solidFill>
-                <a:latin typeface="Antonio Bold" panose="020B0604020202020204" charset="0"/>
+                <a:latin typeface="Segoe UI" panose="020B0502040204020203" pitchFamily="34" charset="0"/>
               </a:rPr>
               <a:t>STEP 1 : Inbound Request Ingestion</a:t>
             </a:r>
           </a:p>
           <a:p>
             <a:pPr algn="ctr"/>
-            <a:endParaRPr lang="en-US" sz="1700" b="1">
+            <a:endParaRPr lang="en-US" sz="1450" b="1">
               <a:solidFill>
                 <a:srgbClr val="06B6D4"/>
               </a:solidFill>
-              <a:latin typeface="Antonio Bold" panose="020B0604020202020204" charset="0"/>
+              <a:latin typeface="Segoe UI" panose="020B0502040204020203" pitchFamily="34" charset="0"/>
             </a:endParaRPr>
           </a:p>
           <a:p>
             <a:pPr algn="ctr"/>
             <a:r>
-              <a:rPr lang="en-US" sz="1400">
+              <a:rPr lang="en-US" sz="1300">
                 <a:solidFill>
                   <a:srgbClr val="E2E8F0"/>
                 </a:solidFill>
@@ -4980,7 +4976,7 @@
           <p:cNvPr id="3" name="Rectangle: Rounded Corners 2">
             <a:extLst>
               <a:ext uri="{FF2B5EF4-FFF2-40B4-BE49-F238E27FC236}">
-                <a16:creationId xmlns:a16="http://schemas.microsoft.com/office/drawing/2014/main" id="{48E46331-396D-99B3-20A3-B780331B4BED}"/>
+                <a16:creationId xmlns:a16="http://schemas.microsoft.com/office/drawing/2014/main" id="{59F004EB-7CB8-9569-DB89-D4FDF14CAAC3}"/>
               </a:ext>
             </a:extLst>
           </p:cNvPr>
@@ -4990,7 +4986,7 @@
         <p:spPr>
           <a:xfrm>
             <a:off x="6921500" y="1778000"/>
-            <a:ext cx="5016500" cy="3492500"/>
+            <a:ext cx="5016500" cy="3556000"/>
           </a:xfrm>
           <a:prstGeom prst="roundRect">
             <a:avLst/>
@@ -5021,33 +5017,33 @@
           </a:fontRef>
         </p:style>
         <p:txBody>
-          <a:bodyPr lIns="317500" tIns="254000" rIns="317500" rtlCol="0" anchor="ctr"/>
-          <a:lstStyle/>
-          <a:p>
-            <a:pPr algn="ctr"/>
-            <a:r>
-              <a:rPr lang="en-US" sz="1700" b="1">
+          <a:bodyPr lIns="317500" tIns="317500" rIns="317500" rtlCol="0" anchor="ctr"/>
+          <a:lstStyle/>
+          <a:p>
+            <a:pPr algn="ctr"/>
+            <a:r>
+              <a:rPr lang="en-US" sz="1450" b="1">
                 <a:solidFill>
                   <a:srgbClr val="22C55E"/>
                 </a:solidFill>
-                <a:latin typeface="Antonio Bold" panose="020B0604020202020204" charset="0"/>
+                <a:latin typeface="Segoe UI" panose="020B0502040204020203" pitchFamily="34" charset="0"/>
               </a:rPr>
               <a:t>STEP 2 : Deep Payload Caching</a:t>
             </a:r>
           </a:p>
           <a:p>
             <a:pPr algn="ctr"/>
-            <a:endParaRPr lang="en-US" sz="1700" b="1">
+            <a:endParaRPr lang="en-US" sz="1450" b="1">
               <a:solidFill>
                 <a:srgbClr val="22C55E"/>
               </a:solidFill>
-              <a:latin typeface="Antonio Bold" panose="020B0604020202020204" charset="0"/>
+              <a:latin typeface="Segoe UI" panose="020B0502040204020203" pitchFamily="34" charset="0"/>
             </a:endParaRPr>
           </a:p>
           <a:p>
             <a:pPr algn="ctr"/>
             <a:r>
-              <a:rPr lang="en-US" sz="1400">
+              <a:rPr lang="en-US" sz="1300">
                 <a:solidFill>
                   <a:srgbClr val="E2E8F0"/>
                 </a:solidFill>
@@ -5063,7 +5059,7 @@
           <p:cNvPr id="5" name="Rectangle: Rounded Corners 4">
             <a:extLst>
               <a:ext uri="{FF2B5EF4-FFF2-40B4-BE49-F238E27FC236}">
-                <a16:creationId xmlns:a16="http://schemas.microsoft.com/office/drawing/2014/main" id="{CCDF1271-9C5C-93AF-956E-6E1E7C6BD42D}"/>
+                <a16:creationId xmlns:a16="http://schemas.microsoft.com/office/drawing/2014/main" id="{9A3A7339-690F-63CF-4D3C-4516A7929109}"/>
               </a:ext>
             </a:extLst>
           </p:cNvPr>
@@ -5073,7 +5069,7 @@
         <p:spPr>
           <a:xfrm>
             <a:off x="12382500" y="1778000"/>
-            <a:ext cx="5016500" cy="3492500"/>
+            <a:ext cx="5016500" cy="3556000"/>
           </a:xfrm>
           <a:prstGeom prst="roundRect">
             <a:avLst/>
@@ -5104,33 +5100,33 @@
           </a:fontRef>
         </p:style>
         <p:txBody>
-          <a:bodyPr lIns="317500" tIns="254000" rIns="317500" rtlCol="0" anchor="ctr"/>
-          <a:lstStyle/>
-          <a:p>
-            <a:pPr algn="ctr"/>
-            <a:r>
-              <a:rPr lang="en-US" sz="1700" b="1">
+          <a:bodyPr lIns="317500" tIns="317500" rIns="317500" rtlCol="0" anchor="ctr"/>
+          <a:lstStyle/>
+          <a:p>
+            <a:pPr algn="ctr"/>
+            <a:r>
+              <a:rPr lang="en-US" sz="1450" b="1">
                 <a:solidFill>
                   <a:srgbClr val="06B6D4"/>
                 </a:solidFill>
-                <a:latin typeface="Antonio Bold" panose="020B0604020202020204" charset="0"/>
+                <a:latin typeface="Segoe UI" panose="020B0502040204020203" pitchFamily="34" charset="0"/>
               </a:rPr>
               <a:t>STEP 3 : Multi-Vector Heuristics</a:t>
             </a:r>
           </a:p>
           <a:p>
             <a:pPr algn="ctr"/>
-            <a:endParaRPr lang="en-US" sz="1700" b="1">
+            <a:endParaRPr lang="en-US" sz="1450" b="1">
               <a:solidFill>
                 <a:srgbClr val="06B6D4"/>
               </a:solidFill>
-              <a:latin typeface="Antonio Bold" panose="020B0604020202020204" charset="0"/>
+              <a:latin typeface="Segoe UI" panose="020B0502040204020203" pitchFamily="34" charset="0"/>
             </a:endParaRPr>
           </a:p>
           <a:p>
             <a:pPr algn="ctr"/>
             <a:r>
-              <a:rPr lang="en-US" sz="1400">
+              <a:rPr lang="en-US" sz="1300">
                 <a:solidFill>
                   <a:srgbClr val="E2E8F0"/>
                 </a:solidFill>
@@ -5146,7 +5142,7 @@
           <p:cNvPr id="6" name="Rectangle: Rounded Corners 5">
             <a:extLst>
               <a:ext uri="{FF2B5EF4-FFF2-40B4-BE49-F238E27FC236}">
-                <a16:creationId xmlns:a16="http://schemas.microsoft.com/office/drawing/2014/main" id="{9CA66175-2463-7B15-2715-6A81FB3CBE40}"/>
+                <a16:creationId xmlns:a16="http://schemas.microsoft.com/office/drawing/2014/main" id="{C16FC69E-04B8-64D9-0D3B-0293FE9C1DD3}"/>
               </a:ext>
             </a:extLst>
           </p:cNvPr>
@@ -5155,8 +5151,8 @@
         </p:nvSpPr>
         <p:spPr>
           <a:xfrm>
-            <a:off x="1460500" y="5651500"/>
-            <a:ext cx="5016500" cy="3492500"/>
+            <a:off x="1460500" y="5715000"/>
+            <a:ext cx="5016500" cy="3556000"/>
           </a:xfrm>
           <a:prstGeom prst="roundRect">
             <a:avLst/>
@@ -5187,33 +5183,33 @@
           </a:fontRef>
         </p:style>
         <p:txBody>
-          <a:bodyPr lIns="317500" tIns="254000" rIns="317500" rtlCol="0" anchor="ctr"/>
-          <a:lstStyle/>
-          <a:p>
-            <a:pPr algn="ctr"/>
-            <a:r>
-              <a:rPr lang="en-US" sz="1700" b="1">
+          <a:bodyPr lIns="317500" tIns="317500" rIns="317500" rtlCol="0" anchor="ctr"/>
+          <a:lstStyle/>
+          <a:p>
+            <a:pPr algn="ctr"/>
+            <a:r>
+              <a:rPr lang="en-US" sz="1450" b="1">
                 <a:solidFill>
                   <a:srgbClr val="22C55E"/>
                 </a:solidFill>
-                <a:latin typeface="Antonio Bold" panose="020B0604020202020204" charset="0"/>
+                <a:latin typeface="Segoe UI" panose="020B0502040204020203" pitchFamily="34" charset="0"/>
               </a:rPr>
               <a:t>STEP 4 : Dynamic Threat Scoring</a:t>
             </a:r>
           </a:p>
           <a:p>
             <a:pPr algn="ctr"/>
-            <a:endParaRPr lang="en-US" sz="1700" b="1">
+            <a:endParaRPr lang="en-US" sz="1450" b="1">
               <a:solidFill>
                 <a:srgbClr val="22C55E"/>
               </a:solidFill>
-              <a:latin typeface="Antonio Bold" panose="020B0604020202020204" charset="0"/>
+              <a:latin typeface="Segoe UI" panose="020B0502040204020203" pitchFamily="34" charset="0"/>
             </a:endParaRPr>
           </a:p>
           <a:p>
             <a:pPr algn="ctr"/>
             <a:r>
-              <a:rPr lang="en-US" sz="1400">
+              <a:rPr lang="en-US" sz="1300">
                 <a:solidFill>
                   <a:srgbClr val="E2E8F0"/>
                 </a:solidFill>
@@ -5229,7 +5225,7 @@
           <p:cNvPr id="7" name="Rectangle: Rounded Corners 6">
             <a:extLst>
               <a:ext uri="{FF2B5EF4-FFF2-40B4-BE49-F238E27FC236}">
-                <a16:creationId xmlns:a16="http://schemas.microsoft.com/office/drawing/2014/main" id="{68D70F8D-F5E1-8015-956A-384865F02C9E}"/>
+                <a16:creationId xmlns:a16="http://schemas.microsoft.com/office/drawing/2014/main" id="{6D907C84-7A9B-6D40-61DC-96B24B47F291}"/>
               </a:ext>
             </a:extLst>
           </p:cNvPr>
@@ -5238,8 +5234,8 @@
         </p:nvSpPr>
         <p:spPr>
           <a:xfrm>
-            <a:off x="6921500" y="5651500"/>
-            <a:ext cx="5016500" cy="3492500"/>
+            <a:off x="6921500" y="5715000"/>
+            <a:ext cx="5016500" cy="3556000"/>
           </a:xfrm>
           <a:prstGeom prst="roundRect">
             <a:avLst/>
@@ -5270,33 +5266,33 @@
           </a:fontRef>
         </p:style>
         <p:txBody>
-          <a:bodyPr lIns="317500" tIns="254000" rIns="317500" rtlCol="0" anchor="ctr"/>
-          <a:lstStyle/>
-          <a:p>
-            <a:pPr algn="ctr"/>
-            <a:r>
-              <a:rPr lang="en-US" sz="1700" b="1">
+          <a:bodyPr lIns="317500" tIns="317500" rIns="317500" rtlCol="0" anchor="ctr"/>
+          <a:lstStyle/>
+          <a:p>
+            <a:pPr algn="ctr"/>
+            <a:r>
+              <a:rPr lang="en-US" sz="1450" b="1">
                 <a:solidFill>
                   <a:srgbClr val="06B6D4"/>
                 </a:solidFill>
-                <a:latin typeface="Antonio Bold" panose="020B0604020202020204" charset="0"/>
+                <a:latin typeface="Segoe UI" panose="020B0502040204020203" pitchFamily="34" charset="0"/>
               </a:rPr>
               <a:t>STEP 5 : Automated Policy Action</a:t>
             </a:r>
           </a:p>
           <a:p>
             <a:pPr algn="ctr"/>
-            <a:endParaRPr lang="en-US" sz="1700" b="1">
+            <a:endParaRPr lang="en-US" sz="1450" b="1">
               <a:solidFill>
                 <a:srgbClr val="06B6D4"/>
               </a:solidFill>
-              <a:latin typeface="Antonio Bold" panose="020B0604020202020204" charset="0"/>
+              <a:latin typeface="Segoe UI" panose="020B0502040204020203" pitchFamily="34" charset="0"/>
             </a:endParaRPr>
           </a:p>
           <a:p>
             <a:pPr algn="ctr"/>
             <a:r>
-              <a:rPr lang="en-US" sz="1400">
+              <a:rPr lang="en-US" sz="1300">
                 <a:solidFill>
                   <a:srgbClr val="E2E8F0"/>
                 </a:solidFill>
@@ -5312,7 +5308,7 @@
           <p:cNvPr id="8" name="Rectangle: Rounded Corners 7">
             <a:extLst>
               <a:ext uri="{FF2B5EF4-FFF2-40B4-BE49-F238E27FC236}">
-                <a16:creationId xmlns:a16="http://schemas.microsoft.com/office/drawing/2014/main" id="{EFC83EB7-A69E-0ACB-CB47-D09B79B5A046}"/>
+                <a16:creationId xmlns:a16="http://schemas.microsoft.com/office/drawing/2014/main" id="{B2E22B53-B5F4-2E7F-B8F8-B7DD290A3D8B}"/>
               </a:ext>
             </a:extLst>
           </p:cNvPr>
@@ -5321,8 +5317,8 @@
         </p:nvSpPr>
         <p:spPr>
           <a:xfrm>
-            <a:off x="12382500" y="5651500"/>
-            <a:ext cx="5016500" cy="3492500"/>
+            <a:off x="12382500" y="5715000"/>
+            <a:ext cx="5016500" cy="3556000"/>
           </a:xfrm>
           <a:prstGeom prst="roundRect">
             <a:avLst/>
@@ -5353,33 +5349,33 @@
           </a:fontRef>
         </p:style>
         <p:txBody>
-          <a:bodyPr lIns="317500" tIns="254000" rIns="317500" rtlCol="0" anchor="ctr"/>
-          <a:lstStyle/>
-          <a:p>
-            <a:pPr algn="ctr"/>
-            <a:r>
-              <a:rPr lang="en-US" sz="1700" b="1">
+          <a:bodyPr lIns="317500" tIns="317500" rIns="317500" rtlCol="0" anchor="ctr"/>
+          <a:lstStyle/>
+          <a:p>
+            <a:pPr algn="ctr"/>
+            <a:r>
+              <a:rPr lang="en-US" sz="1450" b="1">
                 <a:solidFill>
                   <a:srgbClr val="22C55E"/>
                 </a:solidFill>
-                <a:latin typeface="Antonio Bold" panose="020B0604020202020204" charset="0"/>
+                <a:latin typeface="Segoe UI" panose="020B0502040204020203" pitchFamily="34" charset="0"/>
               </a:rPr>
               <a:t>STEP 6 : Forensic Log &amp; SOC Update</a:t>
             </a:r>
           </a:p>
           <a:p>
             <a:pPr algn="ctr"/>
-            <a:endParaRPr lang="en-US" sz="1700" b="1">
+            <a:endParaRPr lang="en-US" sz="1450" b="1">
               <a:solidFill>
                 <a:srgbClr val="22C55E"/>
               </a:solidFill>
-              <a:latin typeface="Antonio Bold" panose="020B0604020202020204" charset="0"/>
+              <a:latin typeface="Segoe UI" panose="020B0502040204020203" pitchFamily="34" charset="0"/>
             </a:endParaRPr>
           </a:p>
           <a:p>
             <a:pPr algn="ctr"/>
             <a:r>
-              <a:rPr lang="en-US" sz="1400">
+              <a:rPr lang="en-US" sz="1300">
                 <a:solidFill>
                   <a:srgbClr val="E2E8F0"/>
                 </a:solidFill>
@@ -5424,7 +5420,7 @@
         <p:spPr>
           <a:xfrm>
             <a:off x="1469107" y="392252"/>
-            <a:ext cx="13898868" cy="1203325"/>
+            <a:ext cx="13898868" cy="1033873"/>
           </a:xfrm>
           <a:prstGeom prst="rect">
             <a:avLst/>
@@ -5442,11 +5438,11 @@
               </a:lnSpc>
             </a:pPr>
             <a:r>
-              <a:rPr lang="en-US" sz="8499" b="1" spc="-212">
+              <a:rPr lang="en-US" sz="4800" b="1" spc="-212">
                 <a:solidFill>
                   <a:srgbClr val="FFFFFF"/>
                 </a:solidFill>
-                <a:latin typeface="Antonio Bold"/>
+                <a:latin typeface="Segoe UI" panose="020B0502040204020203" pitchFamily="34" charset="0"/>
                 <a:ea typeface="Antonio Bold"/>
                 <a:cs typeface="Antonio Bold"/>
                 <a:sym typeface="Antonio Bold"/>
@@ -5461,7 +5457,7 @@
           <p:cNvPr id="2" name="Rectangle: Rounded Corners 1">
             <a:extLst>
               <a:ext uri="{FF2B5EF4-FFF2-40B4-BE49-F238E27FC236}">
-                <a16:creationId xmlns:a16="http://schemas.microsoft.com/office/drawing/2014/main" id="{77060A66-6286-A6AF-B687-C14C34049581}"/>
+                <a16:creationId xmlns:a16="http://schemas.microsoft.com/office/drawing/2014/main" id="{84DA56FF-C7F5-D405-FDDD-1DB110ADA01A}"/>
               </a:ext>
             </a:extLst>
           </p:cNvPr>
@@ -5515,7 +5511,7 @@
           <p:cNvPr id="5" name="Picture 4">
             <a:extLst>
               <a:ext uri="{FF2B5EF4-FFF2-40B4-BE49-F238E27FC236}">
-                <a16:creationId xmlns:a16="http://schemas.microsoft.com/office/drawing/2014/main" id="{18058EE0-1423-D7C2-F0D5-1C9B7BE81A96}"/>
+                <a16:creationId xmlns:a16="http://schemas.microsoft.com/office/drawing/2014/main" id="{2DAE4715-ABE2-7419-C9DF-38F7C145AA3D}"/>
               </a:ext>
             </a:extLst>
           </p:cNvPr>
@@ -5551,7 +5547,7 @@
           <p:cNvPr id="6" name="TextBox 5">
             <a:extLst>
               <a:ext uri="{FF2B5EF4-FFF2-40B4-BE49-F238E27FC236}">
-                <a16:creationId xmlns:a16="http://schemas.microsoft.com/office/drawing/2014/main" id="{DD273FCC-5394-E39B-BEBF-C6803BB2D86A}"/>
+                <a16:creationId xmlns:a16="http://schemas.microsoft.com/office/drawing/2014/main" id="{85090053-1C65-FFFA-1E86-10FADB82545A}"/>
               </a:ext>
             </a:extLst>
           </p:cNvPr>
@@ -5561,7 +5557,7 @@
         <p:spPr>
           <a:xfrm>
             <a:off x="1587500" y="6413500"/>
-            <a:ext cx="7493000" cy="723275"/>
+            <a:ext cx="7493000" cy="715581"/>
           </a:xfrm>
           <a:prstGeom prst="rect">
             <a:avLst/>
@@ -5575,11 +5571,11 @@
           <a:lstStyle/>
           <a:p>
             <a:r>
-              <a:rPr lang="en-US" sz="1600" b="1">
+              <a:rPr lang="en-US" sz="1550" b="1">
                 <a:solidFill>
                   <a:srgbClr val="06B6D4"/>
                 </a:solidFill>
-                <a:latin typeface="Antonio Bold" panose="020B0604020202020204" charset="0"/>
+                <a:latin typeface="Segoe UI" panose="020B0502040204020203" pitchFamily="34" charset="0"/>
               </a:rPr>
               <a:t>Security Operations Center (SOC) Dashboard</a:t>
             </a:r>
@@ -5602,7 +5598,7 @@
           <p:cNvPr id="7" name="Rectangle: Rounded Corners 6">
             <a:extLst>
               <a:ext uri="{FF2B5EF4-FFF2-40B4-BE49-F238E27FC236}">
-                <a16:creationId xmlns:a16="http://schemas.microsoft.com/office/drawing/2014/main" id="{D190DA65-F694-2FF5-6E20-E3BB3AC50BDE}"/>
+                <a16:creationId xmlns:a16="http://schemas.microsoft.com/office/drawing/2014/main" id="{5867235E-85BE-BCA9-9B95-716BF8111AB9}"/>
               </a:ext>
             </a:extLst>
           </p:cNvPr>
@@ -5656,7 +5652,7 @@
           <p:cNvPr id="9" name="Picture 8">
             <a:extLst>
               <a:ext uri="{FF2B5EF4-FFF2-40B4-BE49-F238E27FC236}">
-                <a16:creationId xmlns:a16="http://schemas.microsoft.com/office/drawing/2014/main" id="{551E255F-F1BE-EA11-AD0E-5DC05966F60A}"/>
+                <a16:creationId xmlns:a16="http://schemas.microsoft.com/office/drawing/2014/main" id="{96BCB81D-0CDA-33E7-4AB6-21D9790F329D}"/>
               </a:ext>
             </a:extLst>
           </p:cNvPr>
@@ -5692,7 +5688,7 @@
           <p:cNvPr id="10" name="TextBox 9">
             <a:extLst>
               <a:ext uri="{FF2B5EF4-FFF2-40B4-BE49-F238E27FC236}">
-                <a16:creationId xmlns:a16="http://schemas.microsoft.com/office/drawing/2014/main" id="{DE0D7997-6453-1848-3F2D-39B035C69A1A}"/>
+                <a16:creationId xmlns:a16="http://schemas.microsoft.com/office/drawing/2014/main" id="{4F52418B-4A65-4ACF-079F-187F921165B0}"/>
               </a:ext>
             </a:extLst>
           </p:cNvPr>
@@ -5702,7 +5698,7 @@
         <p:spPr>
           <a:xfrm>
             <a:off x="9779000" y="6413500"/>
-            <a:ext cx="7493000" cy="723275"/>
+            <a:ext cx="7493000" cy="715581"/>
           </a:xfrm>
           <a:prstGeom prst="rect">
             <a:avLst/>
@@ -5716,11 +5712,11 @@
           <a:lstStyle/>
           <a:p>
             <a:r>
-              <a:rPr lang="en-US" sz="1600" b="1">
+              <a:rPr lang="en-US" sz="1550" b="1">
                 <a:solidFill>
                   <a:srgbClr val="22C55E"/>
                 </a:solidFill>
-                <a:latin typeface="Antonio Bold" panose="020B0604020202020204" charset="0"/>
+                <a:latin typeface="Segoe UI" panose="020B0502040204020203" pitchFamily="34" charset="0"/>
               </a:rPr>
               <a:t>Interactive Attack Simulator &amp; Forensic Inspector</a:t>
             </a:r>
@@ -5743,7 +5739,7 @@
           <p:cNvPr id="11" name="Rectangle: Rounded Corners 10">
             <a:extLst>
               <a:ext uri="{FF2B5EF4-FFF2-40B4-BE49-F238E27FC236}">
-                <a16:creationId xmlns:a16="http://schemas.microsoft.com/office/drawing/2014/main" id="{3CFC6DFF-AA2E-2DD4-19B6-A668295E2887}"/>
+                <a16:creationId xmlns:a16="http://schemas.microsoft.com/office/drawing/2014/main" id="{414B0F04-E6F4-B555-F48B-B51D8B90660C}"/>
               </a:ext>
             </a:extLst>
           </p:cNvPr>
@@ -5789,11 +5785,11 @@
           <a:p>
             <a:pPr algn="ctr"/>
             <a:r>
-              <a:rPr lang="en-US" sz="1400" b="1">
+              <a:rPr lang="en-US" sz="1350" b="1">
                 <a:solidFill>
                   <a:srgbClr val="22C55E"/>
                 </a:solidFill>
-                <a:latin typeface="Antonio Bold" panose="020B0604020202020204" charset="0"/>
+                <a:latin typeface="Segoe UI" panose="020B0502040204020203" pitchFamily="34" charset="0"/>
               </a:rPr>
               <a:t>LIVE DEPLOYED DEMO LINKS (CLICKABLE IN SUBMISSION) :</a:t>
             </a:r>
@@ -5846,7 +5842,7 @@
         <p:spPr>
           <a:xfrm>
             <a:off x="1469107" y="392252"/>
-            <a:ext cx="17065580" cy="1203328"/>
+            <a:ext cx="17065580" cy="1043491"/>
           </a:xfrm>
           <a:prstGeom prst="rect">
             <a:avLst/>
@@ -5864,11 +5860,11 @@
               </a:lnSpc>
             </a:pPr>
             <a:r>
-              <a:rPr lang="en-US" sz="8500" b="1" spc="-212">
+              <a:rPr lang="en-US" sz="4800" b="1" spc="-212">
                 <a:solidFill>
                   <a:srgbClr val="FFFFFF"/>
                 </a:solidFill>
-                <a:latin typeface="Antonio Bold"/>
+                <a:latin typeface="Segoe UI" panose="020B0502040204020203" pitchFamily="34" charset="0"/>
                 <a:ea typeface="Antonio Bold"/>
                 <a:cs typeface="Antonio Bold"/>
                 <a:sym typeface="Antonio Bold"/>
@@ -5883,7 +5879,7 @@
           <p:cNvPr id="2" name="Rectangle: Rounded Corners 1">
             <a:extLst>
               <a:ext uri="{FF2B5EF4-FFF2-40B4-BE49-F238E27FC236}">
-                <a16:creationId xmlns:a16="http://schemas.microsoft.com/office/drawing/2014/main" id="{78798578-FC5C-377F-0E76-8D93AAFCB353}"/>
+                <a16:creationId xmlns:a16="http://schemas.microsoft.com/office/drawing/2014/main" id="{F6B2B31B-3DF9-404E-2293-6C18147FC01F}"/>
               </a:ext>
             </a:extLst>
           </p:cNvPr>
@@ -5929,11 +5925,11 @@
           <a:p>
             <a:pPr algn="ctr"/>
             <a:r>
-              <a:rPr lang="en-US" b="1">
+              <a:rPr lang="en-US" sz="1600" b="1">
                 <a:solidFill>
                   <a:srgbClr val="06B6D4"/>
                 </a:solidFill>
-                <a:latin typeface="Antonio Bold" panose="020B0604020202020204" charset="0"/>
+                <a:latin typeface="Segoe UI" panose="020B0502040204020203" pitchFamily="34" charset="0"/>
               </a:rPr>
               <a:t>TECHNICAL FEASIBILITY &amp; CLOUD-NATIVE SCALABILITY</a:t>
             </a:r>
@@ -5981,7 +5977,7 @@
           <p:cNvPr id="3" name="Rectangle: Rounded Corners 2">
             <a:extLst>
               <a:ext uri="{FF2B5EF4-FFF2-40B4-BE49-F238E27FC236}">
-                <a16:creationId xmlns:a16="http://schemas.microsoft.com/office/drawing/2014/main" id="{42DB3F04-153A-D773-4F81-AA63326448AD}"/>
+                <a16:creationId xmlns:a16="http://schemas.microsoft.com/office/drawing/2014/main" id="{70D99EBF-3192-03FC-374F-2CE45FD896A0}"/>
               </a:ext>
             </a:extLst>
           </p:cNvPr>
@@ -6027,11 +6023,11 @@
           <a:p>
             <a:pPr algn="ctr"/>
             <a:r>
-              <a:rPr lang="en-US" b="1">
+              <a:rPr lang="en-US" sz="1600" b="1">
                 <a:solidFill>
                   <a:srgbClr val="22C55E"/>
                 </a:solidFill>
-                <a:latin typeface="Antonio Bold" panose="020B0604020202020204" charset="0"/>
+                <a:latin typeface="Segoe UI" panose="020B0502040204020203" pitchFamily="34" charset="0"/>
               </a:rPr>
               <a:t>COMMERCIAL VIABILITY &amp; MARKET ADOPTION</a:t>
             </a:r>
@@ -6079,7 +6075,7 @@
           <p:cNvPr id="5" name="Rectangle: Rounded Corners 4">
             <a:extLst>
               <a:ext uri="{FF2B5EF4-FFF2-40B4-BE49-F238E27FC236}">
-                <a16:creationId xmlns:a16="http://schemas.microsoft.com/office/drawing/2014/main" id="{3FB84291-8E18-4FC8-72DA-494475E77EBD}"/>
+                <a16:creationId xmlns:a16="http://schemas.microsoft.com/office/drawing/2014/main" id="{45651320-CDF1-2205-D216-551424D193AC}"/>
               </a:ext>
             </a:extLst>
           </p:cNvPr>
@@ -6125,11 +6121,11 @@
           <a:p>
             <a:pPr algn="ctr"/>
             <a:r>
-              <a:rPr lang="en-US" b="1">
+              <a:rPr lang="en-US" sz="1600" b="1">
                 <a:solidFill>
                   <a:srgbClr val="06B6D4"/>
                 </a:solidFill>
-                <a:latin typeface="Antonio Bold" panose="020B0604020202020204" charset="0"/>
+                <a:latin typeface="Segoe UI" panose="020B0502040204020203" pitchFamily="34" charset="0"/>
               </a:rPr>
               <a:t>MEASURABLE IMPACT &amp; SOC EMPOWERMENT</a:t>
             </a:r>
@@ -6206,7 +6202,7 @@
         <p:spPr>
           <a:xfrm>
             <a:off x="1469107" y="392252"/>
-            <a:ext cx="13898868" cy="1203325"/>
+            <a:ext cx="13898868" cy="1033873"/>
           </a:xfrm>
           <a:prstGeom prst="rect">
             <a:avLst/>
@@ -6224,11 +6220,11 @@
               </a:lnSpc>
             </a:pPr>
             <a:r>
-              <a:rPr lang="en-US" sz="8499" b="1" spc="-212">
+              <a:rPr lang="en-US" sz="4800" b="1" spc="-212">
                 <a:solidFill>
                   <a:srgbClr val="FFFFFF"/>
                 </a:solidFill>
-                <a:latin typeface="Antonio Bold"/>
+                <a:latin typeface="Segoe UI" panose="020B0502040204020203" pitchFamily="34" charset="0"/>
                 <a:ea typeface="Antonio Bold"/>
                 <a:cs typeface="Antonio Bold"/>
                 <a:sym typeface="Antonio Bold"/>
@@ -6243,7 +6239,7 @@
           <p:cNvPr id="2" name="Rectangle: Rounded Corners 1">
             <a:extLst>
               <a:ext uri="{FF2B5EF4-FFF2-40B4-BE49-F238E27FC236}">
-                <a16:creationId xmlns:a16="http://schemas.microsoft.com/office/drawing/2014/main" id="{0BED8322-7BCD-8D36-F008-F068C358A8B7}"/>
+                <a16:creationId xmlns:a16="http://schemas.microsoft.com/office/drawing/2014/main" id="{FBA8A644-D2B5-CDBF-36DB-6CDA8A945454}"/>
               </a:ext>
             </a:extLst>
           </p:cNvPr>
@@ -6297,7 +6293,7 @@
           <p:cNvPr id="3" name="TextBox 2">
             <a:extLst>
               <a:ext uri="{FF2B5EF4-FFF2-40B4-BE49-F238E27FC236}">
-                <a16:creationId xmlns:a16="http://schemas.microsoft.com/office/drawing/2014/main" id="{99782BE1-5F6A-2E44-28A1-E93E47F30566}"/>
+                <a16:creationId xmlns:a16="http://schemas.microsoft.com/office/drawing/2014/main" id="{AC198B9D-CCB9-89B5-DE81-5BD7D4799D85}"/>
               </a:ext>
             </a:extLst>
           </p:cNvPr>
@@ -6307,7 +6303,7 @@
         <p:spPr>
           <a:xfrm>
             <a:off x="1841500" y="2222500"/>
-            <a:ext cx="6921500" cy="669414"/>
+            <a:ext cx="6921500" cy="623248"/>
           </a:xfrm>
           <a:prstGeom prst="rect">
             <a:avLst/>
@@ -6321,11 +6317,11 @@
           <a:lstStyle/>
           <a:p>
             <a:r>
-              <a:rPr lang="en-US" sz="2400" b="1">
+              <a:rPr lang="en-US" sz="2100" b="1">
                 <a:solidFill>
                   <a:srgbClr val="22C55E"/>
                 </a:solidFill>
-                <a:latin typeface="Antonio Bold" panose="020B0604020202020204" charset="0"/>
+                <a:latin typeface="Segoe UI" panose="020B0502040204020203" pitchFamily="34" charset="0"/>
               </a:rPr>
               <a:t>LIVE DEMO PLATFORM</a:t>
             </a:r>
@@ -6349,7 +6345,7 @@
             <a:hlinkClick r:id="rId2"/>
             <a:extLst>
               <a:ext uri="{FF2B5EF4-FFF2-40B4-BE49-F238E27FC236}">
-                <a16:creationId xmlns:a16="http://schemas.microsoft.com/office/drawing/2014/main" id="{3026D008-2D1D-1733-DED1-70919402F2FB}"/>
+                <a16:creationId xmlns:a16="http://schemas.microsoft.com/office/drawing/2014/main" id="{5D706485-A8EE-CC10-DE8E-5A1666191231}"/>
               </a:ext>
             </a:extLst>
           </p:cNvPr>
@@ -6395,7 +6391,7 @@
           <a:p>
             <a:pPr algn="ctr"/>
             <a:r>
-              <a:rPr lang="en-US" sz="1600" b="1">
+              <a:rPr lang="en-US" sz="1550" b="1">
                 <a:solidFill>
                   <a:srgbClr val="FFFFFF"/>
                 </a:solidFill>
@@ -6411,7 +6407,7 @@
           <p:cNvPr id="6" name="TextBox 5">
             <a:extLst>
               <a:ext uri="{FF2B5EF4-FFF2-40B4-BE49-F238E27FC236}">
-                <a16:creationId xmlns:a16="http://schemas.microsoft.com/office/drawing/2014/main" id="{9133F72B-CE81-6BF1-A96A-B9D8297AAC63}"/>
+                <a16:creationId xmlns:a16="http://schemas.microsoft.com/office/drawing/2014/main" id="{69B0C223-2ECE-D21F-91FE-B5AEB6193344}"/>
               </a:ext>
             </a:extLst>
           </p:cNvPr>
@@ -6421,7 +6417,7 @@
         <p:spPr>
           <a:xfrm>
             <a:off x="1841500" y="4000500"/>
-            <a:ext cx="6921500" cy="3254737"/>
+            <a:ext cx="6921500" cy="3239348"/>
           </a:xfrm>
           <a:prstGeom prst="rect">
             <a:avLst/>
@@ -6435,21 +6431,21 @@
           <a:lstStyle/>
           <a:p>
             <a:r>
-              <a:rPr lang="en-US" sz="1500" b="1">
+              <a:rPr lang="en-US" sz="1450" b="1">
                 <a:solidFill>
                   <a:srgbClr val="22C55E"/>
                 </a:solidFill>
-                <a:latin typeface="Antonio Bold" panose="020B0604020202020204" charset="0"/>
+                <a:latin typeface="Segoe UI" panose="020B0502040204020203" pitchFamily="34" charset="0"/>
               </a:rPr>
               <a:t>PLATFORM CAPABILITIES:</a:t>
             </a:r>
           </a:p>
           <a:p>
-            <a:endParaRPr lang="en-US" sz="1500" b="1">
+            <a:endParaRPr lang="en-US" sz="1450" b="1">
               <a:solidFill>
                 <a:srgbClr val="22C55E"/>
               </a:solidFill>
-              <a:latin typeface="Antonio Bold" panose="020B0604020202020204" charset="0"/>
+              <a:latin typeface="Segoe UI" panose="020B0502040204020203" pitchFamily="34" charset="0"/>
             </a:endParaRPr>
           </a:p>
           <a:p>
@@ -6546,7 +6542,7 @@
           <p:cNvPr id="7" name="Rectangle: Rounded Corners 6">
             <a:extLst>
               <a:ext uri="{FF2B5EF4-FFF2-40B4-BE49-F238E27FC236}">
-                <a16:creationId xmlns:a16="http://schemas.microsoft.com/office/drawing/2014/main" id="{7CCD105B-DFB8-D945-FAFB-532E30601A11}"/>
+                <a16:creationId xmlns:a16="http://schemas.microsoft.com/office/drawing/2014/main" id="{30C6DF3A-85EE-77A3-81EA-D4B99CAFC472}"/>
               </a:ext>
             </a:extLst>
           </p:cNvPr>
@@ -6600,7 +6596,7 @@
           <p:cNvPr id="8" name="TextBox 7">
             <a:extLst>
               <a:ext uri="{FF2B5EF4-FFF2-40B4-BE49-F238E27FC236}">
-                <a16:creationId xmlns:a16="http://schemas.microsoft.com/office/drawing/2014/main" id="{3816997D-4EFC-F085-0715-9933EA35C05E}"/>
+                <a16:creationId xmlns:a16="http://schemas.microsoft.com/office/drawing/2014/main" id="{6A5295D6-CCC9-AC0E-2A17-54D4ACEC43E3}"/>
               </a:ext>
             </a:extLst>
           </p:cNvPr>
@@ -6610,7 +6606,7 @@
         <p:spPr>
           <a:xfrm>
             <a:off x="10096500" y="2222500"/>
-            <a:ext cx="6921500" cy="669414"/>
+            <a:ext cx="6921500" cy="623248"/>
           </a:xfrm>
           <a:prstGeom prst="rect">
             <a:avLst/>
@@ -6624,11 +6620,11 @@
           <a:lstStyle/>
           <a:p>
             <a:r>
-              <a:rPr lang="en-US" sz="2400" b="1">
+              <a:rPr lang="en-US" sz="2100" b="1">
                 <a:solidFill>
                   <a:srgbClr val="06B6D4"/>
                 </a:solidFill>
-                <a:latin typeface="Antonio Bold" panose="020B0604020202020204" charset="0"/>
+                <a:latin typeface="Segoe UI" panose="020B0502040204020203" pitchFamily="34" charset="0"/>
               </a:rPr>
               <a:t>GITHUB REPOSITORY</a:t>
             </a:r>
@@ -6658,7 +6654,7 @@
             <a:hlinkClick r:id="rId3"/>
             <a:extLst>
               <a:ext uri="{FF2B5EF4-FFF2-40B4-BE49-F238E27FC236}">
-                <a16:creationId xmlns:a16="http://schemas.microsoft.com/office/drawing/2014/main" id="{54BAB015-B0B2-86F6-1E5B-E79911E81D03}"/>
+                <a16:creationId xmlns:a16="http://schemas.microsoft.com/office/drawing/2014/main" id="{823AB02F-1BFA-7FB3-CDB0-8C931DAFE2F7}"/>
               </a:ext>
             </a:extLst>
           </p:cNvPr>
@@ -6704,7 +6700,7 @@
           <a:p>
             <a:pPr algn="ctr"/>
             <a:r>
-              <a:rPr lang="en-US" sz="1450" b="1">
+              <a:rPr lang="en-US" sz="1400" b="1">
                 <a:solidFill>
                   <a:srgbClr val="FFFFFF"/>
                 </a:solidFill>
@@ -6720,7 +6716,7 @@
           <p:cNvPr id="10" name="TextBox 9">
             <a:extLst>
               <a:ext uri="{FF2B5EF4-FFF2-40B4-BE49-F238E27FC236}">
-                <a16:creationId xmlns:a16="http://schemas.microsoft.com/office/drawing/2014/main" id="{31A6E7DC-9EC5-1723-8CD6-7CAAB8AF11EC}"/>
+                <a16:creationId xmlns:a16="http://schemas.microsoft.com/office/drawing/2014/main" id="{2DAF9D4E-4634-939A-3FD6-B91AFCBDB5C3}"/>
               </a:ext>
             </a:extLst>
           </p:cNvPr>
@@ -6730,7 +6726,7 @@
         <p:spPr>
           <a:xfrm>
             <a:off x="10096500" y="4000500"/>
-            <a:ext cx="6921500" cy="3046988"/>
+            <a:ext cx="6921500" cy="3031599"/>
           </a:xfrm>
           <a:prstGeom prst="rect">
             <a:avLst/>
@@ -6744,21 +6740,21 @@
           <a:lstStyle/>
           <a:p>
             <a:r>
-              <a:rPr lang="en-US" sz="1500" b="1">
+              <a:rPr lang="en-US" sz="1450" b="1">
                 <a:solidFill>
                   <a:srgbClr val="06B6D4"/>
                 </a:solidFill>
-                <a:latin typeface="Antonio Bold" panose="020B0604020202020204" charset="0"/>
+                <a:latin typeface="Segoe UI" panose="020B0502040204020203" pitchFamily="34" charset="0"/>
               </a:rPr>
               <a:t>REPOSITORY CONTENTS:</a:t>
             </a:r>
           </a:p>
           <a:p>
-            <a:endParaRPr lang="en-US" sz="1500" b="1">
+            <a:endParaRPr lang="en-US" sz="1450" b="1">
               <a:solidFill>
                 <a:srgbClr val="06B6D4"/>
               </a:solidFill>
-              <a:latin typeface="Antonio Bold" panose="020B0604020202020204" charset="0"/>
+              <a:latin typeface="Segoe UI" panose="020B0502040204020203" pitchFamily="34" charset="0"/>
             </a:endParaRPr>
           </a:p>
           <a:p>

</xml_diff>